<commit_message>
docs(deck): state the results of the full deck as preliminary
The full deck presented one-dimensional estimates, a single-gauge
spectrum and an idealised boundary test as settled findings. The wording
now matches the short version: estimates as estimates, the domain and
the design as proposals, the readings of the Senglea spectrum as
provisional, and the boundary as a working configuration. The cover
edited in PowerPoint is carried over by copy_deck_cover.ps1.
</commit_message>
<xml_diff>
--- a/docs/valletta_model_concept_2026-10-08.pptx
+++ b/docs/valletta_model_concept_2026-10-08.pptx
@@ -8,7 +8,7 @@
     <p:notesMasterId r:id="rId21"/>
   </p:notesMasterIdLst>
   <p:sldIdLst>
-    <p:sldId id="256" r:id="rId2"/>
+    <p:sldId id="275" r:id="rId2"/>
     <p:sldId id="257" r:id="rId3"/>
     <p:sldId id="258" r:id="rId4"/>
     <p:sldId id="259" r:id="rId5"/>
@@ -155,7 +155,7 @@
     </p:spTree>
     <p:extLst>
       <p:ext uri="{BB962C8B-B14F-4D97-AF65-F5344CB8AC3E}">
-        <p14:creationId xmlns:p14="http://schemas.microsoft.com/office/powerpoint/2010/main" val="2185280708"/>
+        <p14:creationId xmlns:p14="http://schemas.microsoft.com/office/powerpoint/2010/main" val="2646880679"/>
       </p:ext>
     </p:extLst>
   </p:cSld>
@@ -332,7 +332,7 @@
     </p:spTree>
     <p:extLst>
       <p:ext uri="{BB962C8B-B14F-4D97-AF65-F5344CB8AC3E}">
-        <p14:creationId xmlns:p14="http://schemas.microsoft.com/office/powerpoint/2010/main" val="1024086991"/>
+        <p14:creationId xmlns:p14="http://schemas.microsoft.com/office/powerpoint/2010/main" val="2710600349"/>
       </p:ext>
     </p:extLst>
   </p:cSld>
@@ -1519,7 +1519,7 @@
           <a:p>
             <a:r>
               <a:rPr lang="en-US" dirty="0"/>
-              <a:t>The domain follows from this table. The harbour rows come from the eigenvalue calculation of the following slide and are tested against the Senglea record on the slide after it.</a:t>
+              <a:t>The proposed domain follows from this table. The CMEMS boundary product is not expected to carry energy in the band. The harbour rows come from the eigenvalue calculation of the following slide and are tested against the Senglea record on the slide after it.</a:t>
             </a:r>
           </a:p>
         </p:txBody>
@@ -1693,7 +1693,7 @@
           <a:p>
             <a:r>
               <a:rPr lang="en-US" dirty="0"/>
-              <a:t>Panels, from the upper left. The mean spectrum with its background, the milgħuba band shaded grey and the estimated basin band shaded blue. The ratio of the spectrum to the background, in which the four peaks stand out. The largest oscillation of the admitted windows, 8 November 2021, with a range of 0.35 m at the 23-minute period. The amplitude ratio against the gauges outside the harbour. The four peaks are present on practically every day of both windows, independently of the forcing, and are therefore properties of the geometry. The ratio against Marsaxlokk compares two coastal sites and is not a transfer function from the open sea.</a:t>
+              <a:t>Panels, from the upper left. The mean spectrum with its background, the milgħuba band shaded grey and the estimated basin band shaded blue. The ratio of the spectrum to the background, in which the four peaks stand out. The largest oscillation of the admitted windows, 8 November 2021, with a range of 0.35 m at the 23-minute period. The amplitude ratio against the gauges outside the harbour. The four peaks are present on practically every day of both windows, independently of the forcing, which points to the geometry. The ratio against Marsaxlokk compares two coastal sites and is not a transfer function from the open sea.</a:t>
             </a:r>
           </a:p>
         </p:txBody>
@@ -2222,15 +2222,7 @@
 
 <file path=ppt/slides/slide1.xml><?xml version="1.0" encoding="utf-8"?>
 <p:sld xmlns:a="http://schemas.openxmlformats.org/drawingml/2006/main" xmlns:r="http://schemas.openxmlformats.org/officeDocument/2006/relationships" xmlns:p="http://schemas.openxmlformats.org/presentationml/2006/main">
-  <p:cSld name="Slide 1">
-    <p:bg>
-      <p:bgPr>
-        <a:solidFill>
-          <a:srgbClr val="21295C"/>
-        </a:solidFill>
-        <a:effectLst/>
-      </p:bgPr>
-    </p:bg>
+  <p:cSld>
     <p:spTree>
       <p:nvGrpSpPr>
         <p:cNvPr id="1" name=""/>
@@ -2626,6 +2618,11 @@
         </p:spPr>
       </p:pic>
     </p:spTree>
+    <p:extLst>
+      <p:ext uri="{BB962C8B-B14F-4D97-AF65-F5344CB8AC3E}">
+        <p14:creationId xmlns:p14="http://schemas.microsoft.com/office/powerpoint/2010/main" val="6375194"/>
+      </p:ext>
+    </p:extLst>
   </p:cSld>
   <p:clrMapOvr>
     <a:masterClrMapping/>
@@ -2887,7 +2884,7 @@
         </p:nvGraphicFramePr>
         <p:xfrm>
           <a:off x="566928" y="3566160"/>
-          <a:ext cx="4937760" cy="2057400"/>
+          <a:ext cx="4937760" cy="914400"/>
         </p:xfrm>
         <a:graphic>
           <a:graphicData uri="http://schemas.openxmlformats.org/drawingml/2006/table">
@@ -3792,13 +3789,6 @@
           </a:solidFill>
           <a:ln/>
         </p:spPr>
-        <p:txBody>
-          <a:bodyPr/>
-          <a:lstStyle/>
-          <a:p>
-            <a:endParaRPr lang="it-IT"/>
-          </a:p>
-        </p:txBody>
       </p:sp>
       <p:sp>
         <p:nvSpPr>
@@ -3902,13 +3892,6 @@
           </a:solidFill>
           <a:ln/>
         </p:spPr>
-        <p:txBody>
-          <a:bodyPr/>
-          <a:lstStyle/>
-          <a:p>
-            <a:endParaRPr lang="it-IT"/>
-          </a:p>
-        </p:txBody>
       </p:sp>
       <p:sp>
         <p:nvSpPr>
@@ -3943,7 +3926,7 @@
                 <a:ea typeface="Cambria" pitchFamily="34" charset="-122"/>
                 <a:cs typeface="Cambria" pitchFamily="34" charset="-120"/>
               </a:rPr>
-              <a:t>Vertical, 12 to 15 sigma layers</a:t>
+              <a:t>Vertical, 12 to 15 sigma layers foreseen</a:t>
             </a:r>
             <a:endParaRPr lang="en-US" sz="1400" dirty="0"/>
           </a:p>
@@ -4006,7 +3989,7 @@
                 <a:ea typeface="Calibri" pitchFamily="34" charset="-122"/>
                 <a:cs typeface="Calibri" pitchFamily="34" charset="-120"/>
               </a:rPr>
-              <a:t>Sigma is defensible only because the domain stops short of the escarpment, where the plateau gradient is one part in a thousand.</a:t>
+              <a:t>Sigma layers are considered defensible because the domain stops short of the escarpment, the plateau gradient being one part in a thousand.</a:t>
             </a:r>
             <a:endParaRPr lang="en-US" sz="1200" dirty="0"/>
           </a:p>
@@ -4148,7 +4131,7 @@
                 <a:ea typeface="Cambria" pitchFamily="34" charset="-122"/>
                 <a:cs typeface="Cambria" pitchFamily="34" charset="-120"/>
               </a:rPr>
-              <a:t>Mesh of the domain and its measured cost</a:t>
+              <a:t>Working mesh and its measured cost</a:t>
             </a:r>
             <a:endParaRPr lang="en-US" sz="3200" dirty="0"/>
           </a:p>
@@ -4523,13 +4506,6 @@
           </a:solidFill>
           <a:ln/>
         </p:spPr>
-        <p:txBody>
-          <a:bodyPr/>
-          <a:lstStyle/>
-          <a:p>
-            <a:endParaRPr lang="it-IT"/>
-          </a:p>
-        </p:txBody>
       </p:sp>
       <p:sp>
         <p:nvSpPr>
@@ -4567,7 +4543,7 @@
                 <a:ea typeface="Calibri" pitchFamily="34" charset="-122"/>
                 <a:cs typeface="Calibri" pitchFamily="34" charset="-120"/>
               </a:rPr>
-              <a:t>Cost of the campaign. </a:t>
+              <a:t>Indicative cost of the campaign. </a:t>
             </a:r>
             <a:r>
               <a:rPr lang="en-US" sz="1200" dirty="0">
@@ -4578,7 +4554,7 @@
                 <a:ea typeface="Calibri" pitchFamily="34" charset="-122"/>
                 <a:cs typeface="Calibri" pitchFamily="34" charset="-120"/>
               </a:rPr>
-              <a:t>The parametric sweep in two dimensions amounts to some 16 h of serial computation. The three-dimensional runs of renewal and validation, 160 simulated days, amount to some 45 h on 8 MPI processes, scaled from the Stagnone configuration with an uncertainty of a factor of two.</a:t>
+              <a:t>The parametric sweep in two dimensions is estimated at some 16 h of serial computation. The three-dimensional runs of renewal and validation, 160 simulated days, would be of the order of 45 h on 8 MPI processes, scaled from the Stagnone configuration with an uncertainty of a factor of two.</a:t>
             </a:r>
             <a:endParaRPr lang="en-US" sz="1200" dirty="0"/>
           </a:p>
@@ -4720,7 +4696,7 @@
                 <a:ea typeface="Calibri" pitchFamily="34" charset="-122"/>
                 <a:cs typeface="Calibri" pitchFamily="34" charset="-120"/>
               </a:rPr>
-              <a:t>A Gaussian hump of water level released on a flat bed at 150 m with 1500 m cells, each case compared against a reference domain without a boundary.</a:t>
+              <a:t>An idealised test, with a Gaussian hump of water level released on a flat bed at 150 m with 1500 m cells and each case compared against a reference domain without a boundary.</a:t>
             </a:r>
             <a:endParaRPr lang="en-US" sz="1400" dirty="0"/>
           </a:p>
@@ -4766,7 +4742,7 @@
         </p:nvGraphicFramePr>
         <p:xfrm>
           <a:off x="6446520" y="2103120"/>
-          <a:ext cx="5175504" cy="1389888"/>
+          <a:ext cx="5175504" cy="914400"/>
         </p:xfrm>
         <a:graphic>
           <a:graphicData uri="http://schemas.openxmlformats.org/drawingml/2006/table">
@@ -5664,13 +5640,6 @@
           </a:solidFill>
           <a:ln/>
         </p:spPr>
-        <p:txBody>
-          <a:bodyPr/>
-          <a:lstStyle/>
-          <a:p>
-            <a:endParaRPr lang="it-IT"/>
-          </a:p>
-        </p:txBody>
       </p:sp>
       <p:sp>
         <p:nvSpPr>
@@ -5705,7 +5674,7 @@
                 <a:ea typeface="Cambria" pitchFamily="34" charset="-122"/>
                 <a:cs typeface="Cambria" pitchFamily="34" charset="-120"/>
               </a:rPr>
-              <a:t>Configuration adopted</a:t>
+              <a:t>Working configuration</a:t>
             </a:r>
             <a:endParaRPr lang="en-US" sz="1350" dirty="0"/>
           </a:p>
@@ -5774,13 +5743,6 @@
           </a:solidFill>
           <a:ln/>
         </p:spPr>
-        <p:txBody>
-          <a:bodyPr/>
-          <a:lstStyle/>
-          <a:p>
-            <a:endParaRPr lang="it-IT"/>
-          </a:p>
-        </p:txBody>
       </p:sp>
       <p:sp>
         <p:nvSpPr>
@@ -5960,7 +5922,7 @@
                 <a:ea typeface="Cambria" pitchFamily="34" charset="-122"/>
                 <a:cs typeface="Cambria" pitchFamily="34" charset="-120"/>
               </a:rPr>
-              <a:t>Existing work and the matters it leaves untreated</a:t>
+              <a:t>Existing work and the scope of the present study</a:t>
             </a:r>
             <a:endParaRPr lang="en-US" sz="3200" dirty="0"/>
           </a:p>
@@ -6150,13 +6112,6 @@
           </a:solidFill>
           <a:ln/>
         </p:spPr>
-        <p:txBody>
-          <a:bodyPr/>
-          <a:lstStyle/>
-          <a:p>
-            <a:endParaRPr lang="it-IT"/>
-          </a:p>
-        </p:txBody>
       </p:sp>
       <p:sp>
         <p:nvSpPr>
@@ -6333,13 +6288,6 @@
           </a:solidFill>
           <a:ln/>
         </p:spPr>
-        <p:txBody>
-          <a:bodyPr/>
-          <a:lstStyle/>
-          <a:p>
-            <a:endParaRPr lang="it-IT"/>
-          </a:p>
-        </p:txBody>
       </p:sp>
       <p:sp>
         <p:nvSpPr>
@@ -6546,13 +6494,6 @@
           </a:solidFill>
           <a:ln/>
         </p:spPr>
-        <p:txBody>
-          <a:bodyPr/>
-          <a:lstStyle/>
-          <a:p>
-            <a:endParaRPr lang="it-IT"/>
-          </a:p>
-        </p:txBody>
       </p:sp>
       <p:sp>
         <p:nvSpPr>
@@ -6699,7 +6640,7 @@
                 <a:ea typeface="Calibri" pitchFamily="34" charset="-122"/>
                 <a:cs typeface="Calibri" pitchFamily="34" charset="-120"/>
               </a:rPr>
-              <a:t>The prior work treats the response of a basin to a wave already present at its boundary, so the generation side is not repeated.</a:t>
+              <a:t>The published work treats the response of a basin to a wave already present at its boundary, so the generation side appears to be open.</a:t>
             </a:r>
             <a:endParaRPr lang="en-US" sz="1200" dirty="0"/>
           </a:p>
@@ -6850,7 +6791,7 @@
                 <a:ea typeface="Calibri" pitchFamily="34" charset="-122"/>
                 <a:cs typeface="Calibri" pitchFamily="34" charset="-120"/>
               </a:rPr>
-              <a:t>Neither treats the generation of the long wave, the circulation of the harbour, or its renewal.</a:t>
+              <a:t>Neither appears to treat the generation of the long wave, the circulation of the harbour, or its renewal.</a:t>
             </a:r>
             <a:endParaRPr lang="en-US" sz="1200" dirty="0"/>
           </a:p>
@@ -7014,7 +6955,7 @@
         </p:nvGraphicFramePr>
         <p:xfrm>
           <a:off x="566928" y="2286000"/>
-          <a:ext cx="6492240" cy="1905000"/>
+          <a:ext cx="6492240" cy="914400"/>
         </p:xfrm>
         <a:graphic>
           <a:graphicData uri="http://schemas.openxmlformats.org/drawingml/2006/table">
@@ -8832,7 +8773,7 @@
                 <a:ea typeface="Calibri" pitchFamily="34" charset="-122"/>
                 <a:cs typeface="Calibri" pitchFamily="34" charset="-120"/>
               </a:rPr>
-              <a:t>Lengthening of the fundamental period of the Grand Harbour, 16.5 minutes, for a restriction imposed on the measured profile over a reach centred on its narrowest section. The Helmholtz scaling, T ∝ a^(−1∕2), attributes the whole inertia of the mode to the mouth and overstates the shift by a factor of three to ten.</a:t>
+              <a:t>Lengthening of the fundamental period of the Grand Harbour, 16.5 minutes, for a restriction imposed on the measured profile over a reach centred on its narrowest section. The Helmholtz scaling, T ∝ a^(−1∕2), attributes the whole inertia of the mode to the mouth and, on this calculation, overstates the shift by a factor of three to ten.</a:t>
             </a:r>
             <a:endParaRPr lang="en-US" sz="1150" dirty="0"/>
           </a:p>
@@ -8859,13 +8800,6 @@
           </a:solidFill>
           <a:ln/>
         </p:spPr>
-        <p:txBody>
-          <a:bodyPr/>
-          <a:lstStyle/>
-          <a:p>
-            <a:endParaRPr lang="it-IT"/>
-          </a:p>
-        </p:txBody>
       </p:sp>
       <p:sp>
         <p:nvSpPr>
@@ -8942,7 +8876,7 @@
                 <a:ea typeface="Calibri" pitchFamily="34" charset="-122"/>
                 <a:cs typeface="Calibri" pitchFamily="34" charset="-120"/>
               </a:rPr>
-              <a:t>A metre of sea level rise shortens these modes by 3.1 per cent. A restriction of a quarter lengthens them by 1.5 to 4 per cent. The two perturbations are of the same order.</a:t>
+              <a:t>On the measured profile a metre of sea level rise shortens the estimated modes by 3.1 per cent, and a restriction of a quarter lengthens them by 1.5 to 4 per cent. The two perturbations appear to be of the same order.</a:t>
             </a:r>
             <a:endParaRPr lang="en-US" sz="1150" dirty="0"/>
           </a:p>
@@ -8969,13 +8903,6 @@
           </a:solidFill>
           <a:ln/>
         </p:spPr>
-        <p:txBody>
-          <a:bodyPr/>
-          <a:lstStyle/>
-          <a:p>
-            <a:endParaRPr lang="it-IT"/>
-          </a:p>
-        </p:txBody>
       </p:sp>
       <p:sp>
         <p:nvSpPr>
@@ -9010,7 +8937,7 @@
                 <a:ea typeface="Cambria" pitchFamily="34" charset="-122"/>
                 <a:cs typeface="Cambria" pitchFamily="34" charset="-120"/>
               </a:rPr>
-              <a:t>Exchange as the principal quantity</a:t>
+              <a:t>Exchange as the quantity of interest</a:t>
             </a:r>
             <a:endParaRPr lang="en-US" sz="1350" dirty="0"/>
           </a:p>
@@ -9052,7 +8979,7 @@
                 <a:ea typeface="Calibri" pitchFamily="34" charset="-122"/>
                 <a:cs typeface="Calibri" pitchFamily="34" charset="-120"/>
               </a:rPr>
-              <a:t>Reaching the observed band from 18.4 minutes requires an open fraction near 0.1 over several hundred metres. The volume exchanged per cycle scales with the open section directly, so renewal responds more strongly than the mode.</a:t>
+              <a:t>Reaching the observed band from 18.4 minutes would require an open fraction near 0.1 over several hundred metres. The volume exchanged per cycle scales with the open section directly, so renewal is expected to respond more strongly than the mode.</a:t>
             </a:r>
             <a:endParaRPr lang="en-US" sz="1150" dirty="0"/>
           </a:p>
@@ -9233,7 +9160,7 @@
                 <a:ea typeface="Calibri" pitchFamily="34" charset="-122"/>
                 <a:cs typeface="Calibri" pitchFamily="34" charset="-120"/>
               </a:rPr>
-              <a:t>ERA5 does not resolve the atmospheric gravity waves that trigger the phenomenon, so a hindcast of individual events is not attempted.</a:t>
+              <a:t>ERA5 does not resolve the atmospheric gravity waves associated with the phenomenon, so a hindcast of individual events is not attempted.</a:t>
             </a:r>
             <a:endParaRPr lang="en-US" sz="1400" dirty="0"/>
           </a:p>
@@ -9258,13 +9185,6 @@
           </a:solidFill>
           <a:ln/>
         </p:spPr>
-        <p:txBody>
-          <a:bodyPr/>
-          <a:lstStyle/>
-          <a:p>
-            <a:endParaRPr lang="it-IT"/>
-          </a:p>
-        </p:txBody>
       </p:sp>
       <p:sp>
         <p:nvSpPr>
@@ -9405,13 +9325,6 @@
           </a:solidFill>
           <a:ln/>
         </p:spPr>
-        <p:txBody>
-          <a:bodyPr/>
-          <a:lstStyle/>
-          <a:p>
-            <a:endParaRPr lang="it-IT"/>
-          </a:p>
-        </p:txBody>
       </p:sp>
       <p:sp>
         <p:nvSpPr>
@@ -9527,7 +9440,7 @@
                 <a:ea typeface="Calibri" pitchFamily="34" charset="-122"/>
                 <a:cs typeface="Calibri" pitchFamily="34" charset="-120"/>
               </a:rPr>
-              <a:t>The output is a transfer function of the geometry, independent of any particular storm.</a:t>
+              <a:t>The output would be a transfer function of the geometry, independent of any particular storm.</a:t>
             </a:r>
             <a:endParaRPr lang="en-US" sz="1250" dirty="0"/>
           </a:p>
@@ -9552,13 +9465,6 @@
           </a:solidFill>
           <a:ln/>
         </p:spPr>
-        <p:txBody>
-          <a:bodyPr/>
-          <a:lstStyle/>
-          <a:p>
-            <a:endParaRPr lang="it-IT"/>
-          </a:p>
-        </p:txBody>
       </p:sp>
       <p:sp>
         <p:nvSpPr>
@@ -9674,7 +9580,7 @@
                 <a:ea typeface="Calibri" pitchFamily="34" charset="-122"/>
                 <a:cs typeface="Calibri" pitchFamily="34" charset="-120"/>
               </a:rPr>
-              <a:t>The observations serve as the test rather than as the forcing, addressing whether recorded events occur under the conditions identified as resonant.</a:t>
+              <a:t>Recorded events would then be located on the surface, to examine whether they occur under the conditions identified as resonant.</a:t>
             </a:r>
             <a:endParaRPr lang="en-US" sz="1250" dirty="0"/>
           </a:p>
@@ -9701,13 +9607,6 @@
           </a:solidFill>
           <a:ln/>
         </p:spPr>
-        <p:txBody>
-          <a:bodyPr/>
-          <a:lstStyle/>
-          <a:p>
-            <a:endParaRPr lang="it-IT"/>
-          </a:p>
-        </p:txBody>
       </p:sp>
       <p:sp>
         <p:nvSpPr>
@@ -9784,7 +9683,7 @@
                 <a:ea typeface="Calibri" pitchFamily="34" charset="-122"/>
                 <a:cs typeface="Calibri" pitchFamily="34" charset="-120"/>
               </a:rPr>
-              <a:t>A response surface is a property of the geometry, whereas climate change acts on the distribution of the forcing.
+              <a:t>A response surface would be a property of the geometry, whereas climate change acts on the distribution of the forcing.
 </a:t>
             </a:r>
             <a:endParaRPr lang="en-US" sz="1150" dirty="0"/>
@@ -9805,7 +9704,7 @@
                 <a:ea typeface="Calibri" pitchFamily="34" charset="-122"/>
                 <a:cs typeface="Calibri" pitchFamily="34" charset="-120"/>
               </a:rPr>
-              <a:t>The two separate, so the surface is computed once and any later study with synoptic projections may convolve them without repeating the hydrodynamics.
+              <a:t>The two would then separate, so that a later study with synoptic projections could apply them to the surface without repeating the hydrodynamics.
 </a:t>
             </a:r>
             <a:endParaRPr lang="en-US" sz="1150" dirty="0"/>
@@ -9826,7 +9725,7 @@
                 <a:ea typeface="Calibri" pitchFamily="34" charset="-122"/>
                 <a:cs typeface="Calibri" pitchFamily="34" charset="-120"/>
               </a:rPr>
-              <a:t>No climate scenario need be run through the model.</a:t>
+              <a:t>Climate scenarios would then not need to be run through the model.</a:t>
             </a:r>
             <a:endParaRPr lang="en-US" sz="1150" dirty="0"/>
           </a:p>
@@ -9865,7 +9764,7 @@
                 <a:ea typeface="Calibri" pitchFamily="34" charset="-122"/>
                 <a:cs typeface="Calibri" pitchFamily="34" charset="-120"/>
               </a:rPr>
-              <a:t>The milgħuba floods Msida, at the head of Msida Creek inside Marsamxett, together with Marsaskala, Xemxija, Marsaxlokk and Sliema.</a:t>
+              <a:t>The milgħuba is reported to flood Msida, at the head of Msida Creek inside Marsamxett, together with Marsaskala, Xemxija, Marsaxlokk and Sliema.</a:t>
             </a:r>
             <a:endParaRPr lang="en-US" sz="1050" dirty="0"/>
           </a:p>
@@ -10032,13 +9931,6 @@
           </a:solidFill>
           <a:ln/>
         </p:spPr>
-        <p:txBody>
-          <a:bodyPr/>
-          <a:lstStyle/>
-          <a:p>
-            <a:endParaRPr lang="it-IT"/>
-          </a:p>
-        </p:txBody>
       </p:sp>
       <p:sp>
         <p:nvSpPr>
@@ -10182,13 +10074,6 @@
           </a:solidFill>
           <a:ln/>
         </p:spPr>
-        <p:txBody>
-          <a:bodyPr/>
-          <a:lstStyle/>
-          <a:p>
-            <a:endParaRPr lang="it-IT"/>
-          </a:p>
-        </p:txBody>
       </p:sp>
       <p:sp>
         <p:nvSpPr>
@@ -10332,13 +10217,6 @@
           </a:solidFill>
           <a:ln/>
         </p:spPr>
-        <p:txBody>
-          <a:bodyPr/>
-          <a:lstStyle/>
-          <a:p>
-            <a:endParaRPr lang="it-IT"/>
-          </a:p>
-        </p:txBody>
       </p:sp>
       <p:sp>
         <p:nvSpPr>
@@ -10482,13 +10360,6 @@
           </a:solidFill>
           <a:ln/>
         </p:spPr>
-        <p:txBody>
-          <a:bodyPr/>
-          <a:lstStyle/>
-          <a:p>
-            <a:endParaRPr lang="it-IT"/>
-          </a:p>
-        </p:txBody>
       </p:sp>
       <p:sp>
         <p:nvSpPr>
@@ -10607,7 +10478,7 @@
                 <a:ea typeface="Calibri" pitchFamily="34" charset="-122"/>
                 <a:cs typeface="Calibri" pitchFamily="34" charset="-120"/>
               </a:rPr>
-              <a:t>A gauge outside both basins on the same coast separates the two readings of the 23-minute peak, and extends the event record to the years before the Senglea installation.</a:t>
+              <a:t>A gauge outside both basins on the same coast would help separate the two readings of the 23-minute peak, and would extend the event record to the years before the Senglea installation.</a:t>
             </a:r>
             <a:endParaRPr lang="en-US" sz="1100" dirty="0"/>
           </a:p>
@@ -10735,13 +10606,6 @@
           </a:solidFill>
           <a:ln/>
         </p:spPr>
-        <p:txBody>
-          <a:bodyPr/>
-          <a:lstStyle/>
-          <a:p>
-            <a:endParaRPr lang="it-IT"/>
-          </a:p>
-        </p:txBody>
       </p:sp>
       <p:sp>
         <p:nvSpPr>
@@ -10885,13 +10749,6 @@
           </a:solidFill>
           <a:ln/>
         </p:spPr>
-        <p:txBody>
-          <a:bodyPr/>
-          <a:lstStyle/>
-          <a:p>
-            <a:endParaRPr lang="it-IT"/>
-          </a:p>
-        </p:txBody>
       </p:sp>
       <p:sp>
         <p:nvSpPr>
@@ -11035,13 +10892,6 @@
           </a:solidFill>
           <a:ln/>
         </p:spPr>
-        <p:txBody>
-          <a:bodyPr/>
-          <a:lstStyle/>
-          <a:p>
-            <a:endParaRPr lang="it-IT"/>
-          </a:p>
-        </p:txBody>
       </p:sp>
       <p:sp>
         <p:nvSpPr>
@@ -11185,13 +11035,6 @@
           </a:solidFill>
           <a:ln/>
         </p:spPr>
-        <p:txBody>
-          <a:bodyPr/>
-          <a:lstStyle/>
-          <a:p>
-            <a:endParaRPr lang="it-IT"/>
-          </a:p>
-        </p:txBody>
       </p:sp>
       <p:sp>
         <p:nvSpPr>
@@ -11335,13 +11178,6 @@
           </a:solidFill>
           <a:ln/>
         </p:spPr>
-        <p:txBody>
-          <a:bodyPr/>
-          <a:lstStyle/>
-          <a:p>
-            <a:endParaRPr lang="it-IT"/>
-          </a:p>
-        </p:txBody>
       </p:sp>
       <p:sp>
         <p:nvSpPr>
@@ -11485,13 +11321,6 @@
           </a:solidFill>
           <a:ln/>
         </p:spPr>
-        <p:txBody>
-          <a:bodyPr/>
-          <a:lstStyle/>
-          <a:p>
-            <a:endParaRPr lang="it-IT"/>
-          </a:p>
-        </p:txBody>
       </p:sp>
       <p:sp>
         <p:nvSpPr>
@@ -11670,13 +11499,6 @@
           </a:solidFill>
           <a:ln/>
         </p:spPr>
-        <p:txBody>
-          <a:bodyPr/>
-          <a:lstStyle/>
-          <a:p>
-            <a:endParaRPr lang="it-IT"/>
-          </a:p>
-        </p:txBody>
       </p:sp>
       <p:sp>
         <p:nvSpPr>
@@ -11750,7 +11572,7 @@
                 <a:ea typeface="Cambria" pitchFamily="34" charset="-122"/>
                 <a:cs typeface="Cambria" pitchFamily="34" charset="-120"/>
               </a:rPr>
-              <a:t>Sequence to the first production runs</a:t>
+              <a:t>Planned sequence to the first production runs</a:t>
             </a:r>
             <a:endParaRPr lang="en-US" sz="3000" dirty="0"/>
           </a:p>
@@ -11775,13 +11597,6 @@
           </a:solidFill>
           <a:ln/>
         </p:spPr>
-        <p:txBody>
-          <a:bodyPr/>
-          <a:lstStyle/>
-          <a:p>
-            <a:endParaRPr lang="it-IT"/>
-          </a:p>
-        </p:txBody>
       </p:sp>
       <p:sp>
         <p:nvSpPr>
@@ -11816,7 +11631,7 @@
                 <a:ea typeface="Calibri" pitchFamily="34" charset="-122"/>
                 <a:cs typeface="Calibri" pitchFamily="34" charset="-120"/>
               </a:rPr>
-              <a:t>Completed</a:t>
+              <a:t>To date</a:t>
             </a:r>
             <a:endParaRPr lang="en-US" sz="1300" dirty="0"/>
           </a:p>
@@ -11858,7 +11673,7 @@
                 <a:ea typeface="Calibri" pitchFamily="34" charset="-122"/>
                 <a:cs typeface="Calibri" pitchFamily="34" charset="-120"/>
               </a:rPr>
-              <a:t>Basin modes, pulse test of the boundary, Senglea spectrum, mesh of the domain.</a:t>
+              <a:t>First-order basin modes, pulse test of the boundary, Senglea spectrum, working mesh.</a:t>
             </a:r>
             <a:endParaRPr lang="en-US" sz="1200" dirty="0"/>
           </a:p>
@@ -11883,13 +11698,6 @@
           </a:solidFill>
           <a:ln/>
         </p:spPr>
-        <p:txBody>
-          <a:bodyPr/>
-          <a:lstStyle/>
-          <a:p>
-            <a:endParaRPr lang="it-IT"/>
-          </a:p>
-        </p:txBody>
       </p:sp>
       <p:sp>
         <p:nvSpPr>
@@ -11991,13 +11799,6 @@
           </a:solidFill>
           <a:ln/>
         </p:spPr>
-        <p:txBody>
-          <a:bodyPr/>
-          <a:lstStyle/>
-          <a:p>
-            <a:endParaRPr lang="it-IT"/>
-          </a:p>
-        </p:txBody>
       </p:sp>
       <p:sp>
         <p:nvSpPr>
@@ -12099,13 +11900,6 @@
           </a:solidFill>
           <a:ln/>
         </p:spPr>
-        <p:txBody>
-          <a:bodyPr/>
-          <a:lstStyle/>
-          <a:p>
-            <a:endParaRPr lang="it-IT"/>
-          </a:p>
-        </p:txBody>
       </p:sp>
       <p:sp>
         <p:nvSpPr>
@@ -12207,13 +12001,6 @@
           </a:solidFill>
           <a:ln/>
         </p:spPr>
-        <p:txBody>
-          <a:bodyPr/>
-          <a:lstStyle/>
-          <a:p>
-            <a:endParaRPr lang="it-IT"/>
-          </a:p>
-        </p:txBody>
       </p:sp>
       <p:sp>
         <p:nvSpPr>
@@ -12319,13 +12106,6 @@
           </a:solidFill>
           <a:ln/>
         </p:spPr>
-        <p:txBody>
-          <a:bodyPr/>
-          <a:lstStyle/>
-          <a:p>
-            <a:endParaRPr lang="it-IT"/>
-          </a:p>
-        </p:txBody>
       </p:sp>
       <p:sp>
         <p:nvSpPr>
@@ -12429,7 +12209,7 @@
                 <a:ea typeface="Calibri" pitchFamily="34" charset="-122"/>
                 <a:cs typeface="Calibri" pitchFamily="34" charset="-120"/>
               </a:rPr>
-              <a:t>A Valletta configuration would take the same route, so the deliverable is a running pilot rather than a set of figures.
+              <a:t>A Valletta configuration could take the same route, should it prove stable in time, so that the deliverable would be a running pilot.
 </a:t>
             </a:r>
             <a:endParaRPr lang="en-US" sz="1150" dirty="0"/>
@@ -12450,7 +12230,7 @@
                 <a:ea typeface="Calibri" pitchFamily="34" charset="-122"/>
                 <a:cs typeface="Calibri" pitchFamily="34" charset="-120"/>
               </a:rPr>
-              <a:t>This corresponds to the relocatable setup requested in the design report of the group.</a:t>
+              <a:t>This would correspond to the relocatable setup requested in the design report of the group.</a:t>
             </a:r>
             <a:endParaRPr lang="en-US" sz="1150" dirty="0"/>
           </a:p>
@@ -12741,7 +12521,7 @@
         </p:nvGraphicFramePr>
         <p:xfrm>
           <a:off x="6263640" y="2057400"/>
-          <a:ext cx="5358384" cy="2103120"/>
+          <a:ext cx="5358384" cy="914400"/>
         </p:xfrm>
         <a:graphic>
           <a:graphicData uri="http://schemas.openxmlformats.org/drawingml/2006/table">
@@ -14594,13 +14374,6 @@
           </a:solidFill>
           <a:ln/>
         </p:spPr>
-        <p:txBody>
-          <a:bodyPr/>
-          <a:lstStyle/>
-          <a:p>
-            <a:endParaRPr lang="it-IT"/>
-          </a:p>
-        </p:txBody>
       </p:sp>
       <p:sp>
         <p:nvSpPr>
@@ -14621,13 +14394,6 @@
           </a:solidFill>
           <a:ln/>
         </p:spPr>
-        <p:txBody>
-          <a:bodyPr/>
-          <a:lstStyle/>
-          <a:p>
-            <a:endParaRPr lang="it-IT"/>
-          </a:p>
-        </p:txBody>
       </p:sp>
       <p:sp>
         <p:nvSpPr>
@@ -14785,7 +14551,7 @@
                 <a:ea typeface="Calibri" pitchFamily="34" charset="-122"/>
                 <a:cs typeface="Calibri" pitchFamily="34" charset="-120"/>
               </a:rPr>
-              <a:t>The Malta Plateau, 99 to 190 m deep, is resonant with disturbances of 94 to 155 km h⁻¹.</a:t>
+              <a:t>The Malta Plateau, 99 to 190 m deep, would be resonant with disturbances travelling at 94 to 155 km h⁻¹.</a:t>
             </a:r>
             <a:endParaRPr lang="en-US" sz="1100" dirty="0"/>
           </a:p>
@@ -14812,13 +14578,6 @@
           </a:solidFill>
           <a:ln/>
         </p:spPr>
-        <p:txBody>
-          <a:bodyPr/>
-          <a:lstStyle/>
-          <a:p>
-            <a:endParaRPr lang="it-IT"/>
-          </a:p>
-        </p:txBody>
       </p:sp>
       <p:sp>
         <p:nvSpPr>
@@ -14839,13 +14598,6 @@
           </a:solidFill>
           <a:ln/>
         </p:spPr>
-        <p:txBody>
-          <a:bodyPr/>
-          <a:lstStyle/>
-          <a:p>
-            <a:endParaRPr lang="it-IT"/>
-          </a:p>
-        </p:txBody>
       </p:sp>
       <p:sp>
         <p:nvSpPr>
@@ -15030,13 +14782,6 @@
           </a:solidFill>
           <a:ln/>
         </p:spPr>
-        <p:txBody>
-          <a:bodyPr/>
-          <a:lstStyle/>
-          <a:p>
-            <a:endParaRPr lang="it-IT"/>
-          </a:p>
-        </p:txBody>
       </p:sp>
       <p:sp>
         <p:nvSpPr>
@@ -15057,13 +14802,6 @@
           </a:solidFill>
           <a:ln/>
         </p:spPr>
-        <p:txBody>
-          <a:bodyPr/>
-          <a:lstStyle/>
-          <a:p>
-            <a:endParaRPr lang="it-IT"/>
-          </a:p>
-        </p:txBody>
       </p:sp>
       <p:sp>
         <p:nvSpPr>
@@ -15221,7 +14959,7 @@
                 <a:ea typeface="Calibri" pitchFamily="34" charset="-122"/>
                 <a:cs typeface="Calibri" pitchFamily="34" charset="-120"/>
               </a:rPr>
-              <a:t>Fundamental modes of 14.5 to 18.4 minutes in the Grand Harbour and 10.4 to 12.8 in Marsamxett.</a:t>
+              <a:t>First-order estimates place the fundamental modes at 14.5 to 18.4 minutes in the Grand Harbour and 10.4 to 12.8 in Marsamxett.</a:t>
             </a:r>
             <a:endParaRPr lang="en-US" sz="1100" dirty="0"/>
           </a:p>
@@ -15363,7 +15101,7 @@
                 <a:ea typeface="Cambria" pitchFamily="34" charset="-122"/>
                 <a:cs typeface="Cambria" pitchFamily="34" charset="-120"/>
               </a:rPr>
-              <a:t>Natural periods against the observed band</a:t>
+              <a:t>First-order estimates of the natural periods</a:t>
             </a:r>
             <a:endParaRPr lang="en-US" sz="3200" dirty="0"/>
           </a:p>
@@ -15424,7 +15162,7 @@
         </p:nvGraphicFramePr>
         <p:xfrm>
           <a:off x="566928" y="2286000"/>
-          <a:ext cx="7772400" cy="2400300"/>
+          <a:ext cx="7772400" cy="914400"/>
         </p:xfrm>
         <a:graphic>
           <a:graphicData uri="http://schemas.openxmlformats.org/drawingml/2006/table">
@@ -17898,11 +17636,11 @@
         <p:spPr>
           <a:xfrm>
             <a:off x="8641080" y="2286000"/>
-            <a:ext cx="2980944" cy="2743200"/>
+            <a:ext cx="2980944" cy="3246120"/>
           </a:xfrm>
           <a:prstGeom prst="roundRect">
             <a:avLst>
-              <a:gd name="adj" fmla="val 2000"/>
+              <a:gd name="adj" fmla="val 1840"/>
             </a:avLst>
           </a:prstGeom>
           <a:solidFill>
@@ -17910,13 +17648,6 @@
           </a:solidFill>
           <a:ln/>
         </p:spPr>
-        <p:txBody>
-          <a:bodyPr/>
-          <a:lstStyle/>
-          <a:p>
-            <a:endParaRPr lang="it-IT"/>
-          </a:p>
-        </p:txBody>
       </p:sp>
       <p:sp>
         <p:nvSpPr>
@@ -17951,7 +17682,7 @@
                 <a:ea typeface="Cambria" pitchFamily="34" charset="-122"/>
                 <a:cs typeface="Cambria" pitchFamily="34" charset="-120"/>
               </a:rPr>
-              <a:t>Consequence for the domain</a:t>
+              <a:t>Reading for the domain</a:t>
             </a:r>
             <a:endParaRPr lang="en-US" sz="1400" dirty="0"/>
           </a:p>
@@ -17966,7 +17697,7 @@
         <p:spPr>
           <a:xfrm>
             <a:off x="8915400" y="2880360"/>
-            <a:ext cx="2468880" cy="2011680"/>
+            <a:ext cx="2468880" cy="2560320"/>
           </a:xfrm>
           <a:prstGeom prst="rect">
             <a:avLst/>
@@ -17993,7 +17724,7 @@
                 <a:ea typeface="Calibri" pitchFamily="34" charset="-122"/>
                 <a:cs typeface="Calibri" pitchFamily="34" charset="-120"/>
               </a:rPr>
-              <a:t>The harbours respond to a shelf-scale oscillation rather than generating one.
+              <a:t>On these estimates the plateau has natural periods within the band and the harbours above it, which suggests that the harbours respond to a shelf-scale oscillation.
 </a:t>
             </a:r>
             <a:endParaRPr lang="en-US" sz="1150" dirty="0"/>
@@ -18014,7 +17745,7 @@
                 <a:ea typeface="Calibri" pitchFamily="34" charset="-122"/>
                 <a:cs typeface="Calibri" pitchFamily="34" charset="-120"/>
               </a:rPr>
-              <a:t>A domain confined to the harbours holds no resonator in the band, and the CMEMS boundary product carries no energy there.
+              <a:t>A domain confined to the harbours would then hold no resonator in the band.
 </a:t>
             </a:r>
             <a:endParaRPr lang="en-US" sz="1150" dirty="0"/>
@@ -18035,7 +17766,7 @@
                 <a:ea typeface="Calibri" pitchFamily="34" charset="-122"/>
                 <a:cs typeface="Calibri" pitchFamily="34" charset="-120"/>
               </a:rPr>
-              <a:t>The domain is therefore required to contain the plateau.</a:t>
+              <a:t>A domain extending over the plateau is therefore proposed.</a:t>
             </a:r>
             <a:endParaRPr lang="en-US" sz="1150" dirty="0"/>
           </a:p>
@@ -18177,7 +17908,7 @@
                 <a:ea typeface="Cambria" pitchFamily="34" charset="-122"/>
                 <a:cs typeface="Cambria" pitchFamily="34" charset="-120"/>
               </a:rPr>
-              <a:t>Fundamental modes from the measured geometry</a:t>
+              <a:t>Estimated modes from the measured geometry</a:t>
             </a:r>
             <a:endParaRPr lang="en-US" sz="3200" dirty="0"/>
           </a:p>
@@ -18326,7 +18057,7 @@
         </p:nvGraphicFramePr>
         <p:xfrm>
           <a:off x="6675120" y="2157984"/>
-          <a:ext cx="4946904" cy="1975104"/>
+          <a:ext cx="4946904" cy="914400"/>
         </p:xfrm>
         <a:graphic>
           <a:graphicData uri="http://schemas.openxmlformats.org/drawingml/2006/table">
@@ -20061,13 +19792,6 @@
           </a:solidFill>
           <a:ln/>
         </p:spPr>
-        <p:txBody>
-          <a:bodyPr/>
-          <a:lstStyle/>
-          <a:p>
-            <a:endParaRPr lang="it-IT"/>
-          </a:p>
-        </p:txBody>
       </p:sp>
       <p:sp>
         <p:nvSpPr>
@@ -20144,7 +19868,7 @@
                 <a:ea typeface="Calibri" pitchFamily="34" charset="-122"/>
                 <a:cs typeface="Calibri" pitchFamily="34" charset="-120"/>
               </a:rPr>
-              <a:t>Removing the 378 m breakwater changes the period by 0.1 minute. The section at the entrance, 8,780 m², is within 6 per cent of the median section of the basin, so the inertia of the mode is distributed along the harbour and the basin is not a Helmholtz resonator.</a:t>
+              <a:t>Removing the 378 m breakwater changes the estimate by 0.1 minute. The section at the entrance, 8,780 m², is within 6 per cent of the median section of the basin, which suggests that the inertia of the mode is distributed along the harbour rather than concentrated at the mouth.</a:t>
             </a:r>
             <a:endParaRPr lang="en-US" sz="1150" dirty="0"/>
           </a:p>
@@ -20183,7 +19907,7 @@
                 <a:ea typeface="Calibri" pitchFamily="34" charset="-122"/>
                 <a:cs typeface="Calibri" pitchFamily="34" charset="-120"/>
               </a:rPr>
-              <a:t>T₀ omits and T includes the mouth correction of Rabinovich (2009, eq. 9.16). Branches are taken in phase, so only the fundamental is reported.</a:t>
+              <a:t>T₀ omits and T includes the mouth correction of Rabinovich (2009, eq. 9.16). The calculation is one-dimensional and first-order, and only the fundamental is reported.</a:t>
             </a:r>
             <a:endParaRPr lang="en-US" sz="1050" dirty="0"/>
           </a:p>
@@ -20371,7 +20095,7 @@
         </p:nvGraphicFramePr>
         <p:xfrm>
           <a:off x="6583680" y="2103120"/>
-          <a:ext cx="5038344" cy="1645920"/>
+          <a:ext cx="5038344" cy="914400"/>
         </p:xfrm>
         <a:graphic>
           <a:graphicData uri="http://schemas.openxmlformats.org/drawingml/2006/table">
@@ -21803,12 +21527,12 @@
         </p:nvSpPr>
         <p:spPr>
           <a:xfrm>
-            <a:off x="6583680" y="3877056"/>
-            <a:ext cx="5038344" cy="2157984"/>
+            <a:off x="6583680" y="3840480"/>
+            <a:ext cx="5038344" cy="2194560"/>
           </a:xfrm>
           <a:prstGeom prst="roundRect">
             <a:avLst>
-              <a:gd name="adj" fmla="val 2542"/>
+              <a:gd name="adj" fmla="val 2500"/>
             </a:avLst>
           </a:prstGeom>
           <a:solidFill>
@@ -21816,13 +21540,6 @@
           </a:solidFill>
           <a:ln/>
         </p:spPr>
-        <p:txBody>
-          <a:bodyPr/>
-          <a:lstStyle/>
-          <a:p>
-            <a:endParaRPr lang="it-IT"/>
-          </a:p>
-        </p:txBody>
       </p:sp>
       <p:sp>
         <p:nvSpPr>
@@ -21832,7 +21549,7 @@
         </p:nvSpPr>
         <p:spPr>
           <a:xfrm>
-            <a:off x="6858000" y="4041648"/>
+            <a:off x="6858000" y="4005072"/>
             <a:ext cx="4489704" cy="274320"/>
           </a:xfrm>
           <a:prstGeom prst="rect">
@@ -21871,8 +21588,8 @@
         </p:nvSpPr>
         <p:spPr>
           <a:xfrm>
-            <a:off x="6858000" y="4370832"/>
-            <a:ext cx="4489704" cy="1554480"/>
+            <a:off x="6858000" y="4334256"/>
+            <a:ext cx="4489704" cy="1591056"/>
           </a:xfrm>
           <a:prstGeom prst="rect">
             <a:avLst/>
@@ -21903,7 +21620,7 @@
                 <a:ea typeface="Calibri" pitchFamily="34" charset="-122"/>
                 <a:cs typeface="Calibri" pitchFamily="34" charset="-120"/>
               </a:rPr>
-              <a:t>It is the fundamental of the Grand Harbour, which the one-dimensional calculation would then underestimate by about a quarter.</a:t>
+              <a:t>It may be the fundamental of the Grand Harbour, underestimated by about a quarter in the one-dimensional calculation.</a:t>
             </a:r>
             <a:endParaRPr lang="en-US" sz="1150" dirty="0"/>
           </a:p>
@@ -21927,7 +21644,7 @@
                 <a:ea typeface="Calibri" pitchFamily="34" charset="-122"/>
                 <a:cs typeface="Calibri" pitchFamily="34" charset="-120"/>
               </a:rPr>
-              <a:t>The 16.8-minute peak is the fundamental, and the 23-minute peak belongs to the outer approach shared by the two harbours.</a:t>
+              <a:t>Alternatively it may belong to the approach shared by the two harbours, the 16.8-minute peak being the fundamental.</a:t>
             </a:r>
             <a:endParaRPr lang="en-US" sz="1150" dirty="0"/>
           </a:p>
@@ -21947,7 +21664,7 @@
                 <a:ea typeface="Calibri" pitchFamily="34" charset="-122"/>
                 <a:cs typeface="Calibri" pitchFamily="34" charset="-120"/>
               </a:rPr>
-              <a:t>The modal structure computed by the model, or a second gauge, separates the two.</a:t>
+              <a:t>The modal structure computed by the model, or a second gauge, would separate the two.</a:t>
             </a:r>
             <a:endParaRPr lang="en-US" sz="1150" dirty="0"/>
           </a:p>
@@ -21986,7 +21703,7 @@
                 <a:ea typeface="Calibri" pitchFamily="34" charset="-122"/>
                 <a:cs typeface="Calibri" pitchFamily="34" charset="-120"/>
               </a:rPr>
-              <a:t>All peaks lie above the milgħuba band, which holds 12 per cent of the variance between 0.2 and 10 cph. Between 2 and 3 cph the amplitude at Senglea is 2.8 times that at Marsaxlokk.</a:t>
+              <a:t>In the nine months admitted the peaks lie above the milgħuba band. Between 2 and 3 cph the amplitude at Senglea is 2.8 times that at Marsaxlokk.</a:t>
             </a:r>
             <a:endParaRPr lang="en-US" sz="1050" dirty="0"/>
           </a:p>
@@ -22150,7 +21867,7 @@
         </p:nvGraphicFramePr>
         <p:xfrm>
           <a:off x="566928" y="2194560"/>
-          <a:ext cx="11055096" cy="2084832"/>
+          <a:ext cx="11055096" cy="914400"/>
         </p:xfrm>
         <a:graphic>
           <a:graphicData uri="http://schemas.openxmlformats.org/drawingml/2006/table">
@@ -23524,7 +23241,7 @@
                           <a:ea typeface="Calibri" pitchFamily="34" charset="-122"/>
                           <a:cs typeface="Calibri" pitchFamily="34" charset="-120"/>
                         </a:rPr>
-                        <a:t>displaced level, unusable</a:t>
+                        <a:t>displaced level, not usable</a:t>
                       </a:r>
                       <a:endParaRPr lang="en-US" sz="1200" dirty="0">
                         <a:latin typeface="Calibri" charset="0"/>
@@ -23803,7 +23520,7 @@
                           <a:ea typeface="Calibri" pitchFamily="34" charset="-122"/>
                           <a:cs typeface="Calibri" pitchFamily="34" charset="-120"/>
                         </a:rPr>
-                        <a:t>displaced level, unusable</a:t>
+                        <a:t>displaced level, not usable</a:t>
                       </a:r>
                       <a:endParaRPr lang="en-US" sz="1200" dirty="0">
                         <a:latin typeface="Calibri" charset="0"/>
@@ -23885,13 +23602,6 @@
           </a:solidFill>
           <a:ln/>
         </p:spPr>
-        <p:txBody>
-          <a:bodyPr/>
-          <a:lstStyle/>
-          <a:p>
-            <a:endParaRPr lang="it-IT"/>
-          </a:p>
-        </p:txBody>
       </p:sp>
       <p:sp>
         <p:nvSpPr>
@@ -23968,7 +23678,7 @@
                 <a:ea typeface="Calibri" pitchFamily="34" charset="-122"/>
                 <a:cs typeface="Calibri" pitchFamily="34" charset="-120"/>
               </a:rPr>
-              <a:t>Two windows are admitted to the analysis, 24 June to 31 December 2021 and 1 December 2022 to 31 March 2023, on monthly coverage and stability of the level. From April 2023 the level is displaced by some 2 m and the gauge transmits by day only.</a:t>
+              <a:t>Two windows are provisionally admitted to the analysis, 24 June to 31 December 2021 and 1 December 2022 to 31 March 2023, on monthly coverage and stability of the level. From April 2023 the level appears displaced by some 2 m and the gauge transmits by day only.</a:t>
             </a:r>
             <a:endParaRPr lang="en-US" sz="1150" dirty="0"/>
           </a:p>
@@ -23995,13 +23705,6 @@
           </a:solidFill>
           <a:ln/>
         </p:spPr>
-        <p:txBody>
-          <a:bodyPr/>
-          <a:lstStyle/>
-          <a:p>
-            <a:endParaRPr lang="it-IT"/>
-          </a:p>
-        </p:txBody>
       </p:sp>
       <p:sp>
         <p:nvSpPr>
@@ -24078,7 +23781,7 @@
                 <a:ea typeface="Calibri" pitchFamily="34" charset="-122"/>
                 <a:cs typeface="Calibri" pitchFamily="34" charset="-120"/>
               </a:rPr>
-              <a:t>None of the three events since installation is resolved in the public copy, and Portomaso returns no data from the IOC facility on those dates. The archive of the group, sea level and one-minute pressure, is the record against which the response surface is tested.</a:t>
+              <a:t>None of the three events since installation is resolved in the public copy, and Portomaso returns no data from the IOC facility on those dates. The archive of the group, sea level and one-minute pressure, would therefore be the record against which the response surface is tested.</a:t>
             </a:r>
             <a:endParaRPr lang="en-US" sz="1150" dirty="0"/>
           </a:p>

</xml_diff>

<commit_message>
docs(deck): place the two-dimensional sweep in October, ahead of the 3D runs
The sweep needs only the mesh, the boundary and the pressure field, and
its machine cost is of the order of hours, whereas the three-dimensional
runs need the full forcing chain. October therefore carries the boundary
tests under pressure forcing, a pilot scenario, the impulse response and
the sweep, with a first three-dimensional test run, and November the
validation hindcast and the renewal runs.
</commit_message>
<xml_diff>
--- a/docs/valletta_model_concept_2026-10-08.pptx
+++ b/docs/valletta_model_concept_2026-10-08.pptx
@@ -152,7 +152,7 @@
     </p:spTree>
     <p:extLst>
       <p:ext uri="{BB962C8B-B14F-4D97-AF65-F5344CB8AC3E}">
-        <p14:creationId xmlns:p14="http://schemas.microsoft.com/office/powerpoint/2010/main" val="2297757110"/>
+        <p14:creationId xmlns:p14="http://schemas.microsoft.com/office/powerpoint/2010/main" val="1731827398"/>
       </p:ext>
     </p:extLst>
   </p:cSld>
@@ -329,7 +329,7 @@
     </p:spTree>
     <p:extLst>
       <p:ext uri="{BB962C8B-B14F-4D97-AF65-F5344CB8AC3E}">
-        <p14:creationId xmlns:p14="http://schemas.microsoft.com/office/powerpoint/2010/main" val="1742867347"/>
+        <p14:creationId xmlns:p14="http://schemas.microsoft.com/office/powerpoint/2010/main" val="4137804488"/>
       </p:ext>
     </p:extLst>
   </p:cSld>
@@ -907,7 +907,7 @@
           <a:p>
             <a:r>
               <a:rPr lang="en-US" dirty="0"/>
-              <a:t>The broadband impulse yields the modal structure of the harbours on the mesh, which decides between the two readings of the 23-minute peak. The remaining boundary tests are the residual current and the non-zero incoming signal from CMEMS. The block of 27 October to 21 November loses four working days to Delft and holds fifteen rather than nineteen. The EDITO deployment is conditional on the configuration proving stable in time, and it belongs to the last block of the period alongside the integration into the ocean.mt portal.</a:t>
+              <a:t>The broadband impulse yields the modal structure of the harbours on the mesh, which decides between the two readings of the 23-minute peak. The remaining boundary tests are the residual current, the non-zero incoming signal from CMEMS and a pressure disturbance crossing the boundary. The sweep precedes the three-dimensional runs because it needs only the mesh, the boundary and the pressure field, whereas those runs need the full forcing chain. A few scenarios on a larger domain would show whether the extent truncates the Proudman stage. The bathymetry at the heads of Msida and Pietà Creeks is to be completed before the inlets are relied upon. The block of 27 October to 21 November loses four working days to Delft and holds fifteen rather than nineteen. The EDITO deployment is conditional on the configuration proving stable in time, and it belongs to the last block of the period alongside the integration into the ocean.mt portal.</a:t>
             </a:r>
           </a:p>
         </p:txBody>
@@ -2356,7 +2356,7 @@
     </p:spTree>
     <p:extLst>
       <p:ext uri="{BB962C8B-B14F-4D97-AF65-F5344CB8AC3E}">
-        <p14:creationId xmlns:p14="http://schemas.microsoft.com/office/powerpoint/2010/main" val="2738494814"/>
+        <p14:creationId xmlns:p14="http://schemas.microsoft.com/office/powerpoint/2010/main" val="1035187629"/>
       </p:ext>
     </p:extLst>
   </p:cSld>
@@ -8078,7 +8078,7 @@
           <p:cNvPr id="25" name="Picture 24">
             <a:extLst>
               <a:ext uri="{FF2B5EF4-FFF2-40B4-BE49-F238E27FC236}">
-                <a16:creationId xmlns:a16="http://schemas.microsoft.com/office/drawing/2014/main" id="{5BA79DE4-0C66-A2CB-2B47-9F3E0C26F179}"/>
+                <a16:creationId xmlns:a16="http://schemas.microsoft.com/office/drawing/2014/main" id="{0EE0FC90-F192-0AB0-06C6-9B975AFAC200}"/>
               </a:ext>
             </a:extLst>
           </p:cNvPr>
@@ -8437,7 +8437,7 @@
                 <a:ea typeface="Calibri" pitchFamily="34" charset="-122"/>
                 <a:cs typeface="Calibri" pitchFamily="34" charset="-120"/>
               </a:rPr>
-              <a:t>Bathymetry at the heads of Msida and Pietà Creeks, remaining boundary tests, impulse response of the mesh, first three-dimensional runs.</a:t>
+              <a:t>Boundary tests under pressure forcing, pilot scenario and impulse response, then the sweep of the long wave, barotropic and two-dimensional.</a:t>
             </a:r>
             <a:endParaRPr lang="en-US" sz="1200" dirty="0"/>
           </a:p>
@@ -8740,7 +8740,7 @@
                 <a:ea typeface="Calibri" pitchFamily="34" charset="-122"/>
                 <a:cs typeface="Calibri" pitchFamily="34" charset="-120"/>
               </a:rPr>
-              <a:t>Sweep of the long wave, barotropic and therefore two-dimensional, and the validation hindcast.</a:t>
+              <a:t>Three-dimensional runs of the validation hindcast and of renewal, after a first test run in October.</a:t>
             </a:r>
             <a:endParaRPr lang="en-US" sz="1200" dirty="0"/>
           </a:p>

</xml_diff>

<commit_message>
docs(deck): show the gaps of the Senglea record on the events slide
The events slide carried a table alone. It now carries the coverage
figure beside a table reduced to the three events since installation,
the two earlier events being stated in a line. The edits made in
PowerPoint to the closing slide, on the User Days rows, are taken into
the generators so that a rebuild keeps them.
</commit_message>
<xml_diff>
--- a/docs/valletta_model_concept_2026-10-08.pptx
+++ b/docs/valletta_model_concept_2026-10-08.pptx
@@ -152,7 +152,7 @@
     </p:spTree>
     <p:extLst>
       <p:ext uri="{BB962C8B-B14F-4D97-AF65-F5344CB8AC3E}">
-        <p14:creationId xmlns:p14="http://schemas.microsoft.com/office/powerpoint/2010/main" val="1731827398"/>
+        <p14:creationId xmlns:p14="http://schemas.microsoft.com/office/powerpoint/2010/main" val="1819915146"/>
       </p:ext>
     </p:extLst>
   </p:cSld>
@@ -329,7 +329,7 @@
     </p:spTree>
     <p:extLst>
       <p:ext uri="{BB962C8B-B14F-4D97-AF65-F5344CB8AC3E}">
-        <p14:creationId xmlns:p14="http://schemas.microsoft.com/office/powerpoint/2010/main" val="4137804488"/>
+        <p14:creationId xmlns:p14="http://schemas.microsoft.com/office/powerpoint/2010/main" val="2793833867"/>
       </p:ext>
     </p:extLst>
   </p:cSld>
@@ -1429,7 +1429,7 @@
           <a:p>
             <a:r>
               <a:rPr lang="en-US" dirty="0"/>
-              <a:t>Sources. University of Malta Newspoint for 2018 and 2019, Newsbook for 2022, MaltaToday for 2023 and 2024, the last citing the Oceanography Malta Research Group. Upward radar echoes from vessels, rain and spray are removed by the lower envelope of the 5 s samples, and episodes of reference offset of 1.3 to 2.1 m are removed before the spectrum is computed. The choice of windows is to be confirmed within the group. The displaced level is compatible with the radar ranging to a vessel or pontoon beneath it, which is a conjecture.</a:t>
+              <a:t>The figure shows the one-minute level after quality control and the daily coverage, with the two admitted windows shaded and the three events reported since installation marked in orange. On 30 June 2022 the record is absent and resumes on 1 July. In July 2023 and June 2024 the level sits some 2 m above its earlier position with coverage near a half, the gauge transmitting by day only. Sources for the events. University of Malta Newspoint for 2018 and 2019, Newsbook for 2022, MaltaToday for 2023 and 2024, the last citing the Oceanography Malta Research Group. Portomaso returns no data from the IOC facility on those dates. The choice of windows rests on monthly coverage and stability of the level and is to be confirmed within the group.</a:t>
             </a:r>
           </a:p>
         </p:txBody>
@@ -2356,7 +2356,7 @@
     </p:spTree>
     <p:extLst>
       <p:ext uri="{BB962C8B-B14F-4D97-AF65-F5344CB8AC3E}">
-        <p14:creationId xmlns:p14="http://schemas.microsoft.com/office/powerpoint/2010/main" val="1035187629"/>
+        <p14:creationId xmlns:p14="http://schemas.microsoft.com/office/powerpoint/2010/main" val="3998449215"/>
       </p:ext>
     </p:extLst>
   </p:cSld>
@@ -8078,7 +8078,7 @@
           <p:cNvPr id="25" name="Picture 24">
             <a:extLst>
               <a:ext uri="{FF2B5EF4-FFF2-40B4-BE49-F238E27FC236}">
-                <a16:creationId xmlns:a16="http://schemas.microsoft.com/office/drawing/2014/main" id="{0EE0FC90-F192-0AB0-06C6-9B975AFAC200}"/>
+                <a16:creationId xmlns:a16="http://schemas.microsoft.com/office/drawing/2014/main" id="{40741E20-3BC2-4BEC-7C7D-43364A8CBCE2}"/>
               </a:ext>
             </a:extLst>
           </p:cNvPr>
@@ -8538,7 +8538,7 @@
                 <a:ea typeface="Calibri" pitchFamily="34" charset="-122"/>
                 <a:cs typeface="Calibri" pitchFamily="34" charset="-120"/>
               </a:rPr>
-              <a:t>Delft3D User Days abstract.</a:t>
+              <a:t>Delft3D User Days abstract (Stagnone model).</a:t>
             </a:r>
             <a:endParaRPr lang="en-US" sz="1200" dirty="0"/>
           </a:p>
@@ -8639,7 +8639,7 @@
                 <a:ea typeface="Calibri" pitchFamily="34" charset="-122"/>
                 <a:cs typeface="Calibri" pitchFamily="34" charset="-120"/>
               </a:rPr>
-              <a:t>Delft3D User Days at Deltares, with the configuration questions.</a:t>
+              <a:t>Delft3D User Days at Deltares.</a:t>
             </a:r>
             <a:endParaRPr lang="en-US" sz="1200" dirty="0"/>
           </a:p>
@@ -16347,7 +16347,7 @@
                 <a:ea typeface="Calibri" pitchFamily="34" charset="-122"/>
                 <a:cs typeface="Calibri" pitchFamily="34" charset="-120"/>
               </a:rPr>
-              <a:t>OBSERVATION</a:t>
+              <a:t>OBSERVATIONS</a:t>
             </a:r>
             <a:endParaRPr lang="en-US" sz="1200" dirty="0"/>
           </a:p>
@@ -16431,6 +16431,30 @@
           </a:p>
         </p:txBody>
       </p:sp>
+      <p:pic>
+        <p:nvPicPr>
+          <p:cNvPr id="5" name="Image 0" descr="C:\Users\Unipa\Documents\MaltaDT\figures\senglea_coverage_events.png"/>
+          <p:cNvPicPr>
+            <a:picLocks noChangeAspect="1"/>
+          </p:cNvPicPr>
+          <p:nvPr/>
+        </p:nvPicPr>
+        <p:blipFill>
+          <a:blip r:embed="rId3"/>
+          <a:stretch>
+            <a:fillRect/>
+          </a:stretch>
+        </p:blipFill>
+        <p:spPr>
+          <a:xfrm>
+            <a:off x="566928" y="2057400"/>
+            <a:ext cx="6858000" cy="2633472"/>
+          </a:xfrm>
+          <a:prstGeom prst="rect">
+            <a:avLst/>
+          </a:prstGeom>
+        </p:spPr>
+      </p:pic>
       <p:graphicFrame>
         <p:nvGraphicFramePr>
           <p:cNvPr id="8" name="Table 0"/>
@@ -16446,44 +16470,37 @@
           </p:nvPr>
         </p:nvGraphicFramePr>
         <p:xfrm>
-          <a:off x="566928" y="2194560"/>
-          <a:ext cx="11055096" cy="914400"/>
+          <a:off x="7589520" y="2057400"/>
+          <a:ext cx="4032504" cy="914400"/>
         </p:xfrm>
         <a:graphic>
           <a:graphicData uri="http://schemas.openxmlformats.org/drawingml/2006/table">
             <a:tbl>
               <a:tblPr/>
               <a:tblGrid>
-                <a:gridCol w="1371600">
+                <a:gridCol w="960120">
                   <a:extLst>
                     <a:ext uri="{9D8B030D-6E8A-4147-A177-3AD203B41FA5}">
                       <a16:colId xmlns:a16="http://schemas.microsoft.com/office/drawing/2014/main" val="20000"/>
                     </a:ext>
                   </a:extLst>
                 </a:gridCol>
-                <a:gridCol w="1645920">
+                <a:gridCol w="1737360">
                   <a:extLst>
                     <a:ext uri="{9D8B030D-6E8A-4147-A177-3AD203B41FA5}">
                       <a16:colId xmlns:a16="http://schemas.microsoft.com/office/drawing/2014/main" val="20001"/>
                     </a:ext>
                   </a:extLst>
                 </a:gridCol>
-                <a:gridCol w="4480560">
+                <a:gridCol w="1335024">
                   <a:extLst>
                     <a:ext uri="{9D8B030D-6E8A-4147-A177-3AD203B41FA5}">
                       <a16:colId xmlns:a16="http://schemas.microsoft.com/office/drawing/2014/main" val="20002"/>
                     </a:ext>
                   </a:extLst>
                 </a:gridCol>
-                <a:gridCol w="3557016">
-                  <a:extLst>
-                    <a:ext uri="{9D8B030D-6E8A-4147-A177-3AD203B41FA5}">
-                      <a16:colId xmlns:a16="http://schemas.microsoft.com/office/drawing/2014/main" val="20003"/>
-                    </a:ext>
-                  </a:extLst>
-                </a:gridCol>
               </a:tblGrid>
-              <a:tr h="347472">
+              <a:tr h="457200">
                 <a:tc>
                   <a:txBody>
                     <a:bodyPr/>
@@ -16493,7 +16510,7 @@
                         <a:buNone/>
                       </a:pPr>
                       <a:r>
-                        <a:rPr lang="en-US" sz="1200" b="1" dirty="0">
+                        <a:rPr lang="en-US" sz="1050" b="1" dirty="0">
                           <a:solidFill>
                             <a:srgbClr val="FFFFFF"/>
                           </a:solidFill>
@@ -16503,7 +16520,7 @@
                         </a:rPr>
                         <a:t>Date</a:t>
                       </a:r>
-                      <a:endParaRPr lang="en-US" sz="1200" dirty="0">
+                      <a:endParaRPr lang="en-US" sz="1050" dirty="0">
                         <a:latin typeface="Calibri" charset="0"/>
                         <a:ea typeface="Calibri" charset="0"/>
                         <a:cs typeface="Calibri" charset="0"/>
@@ -16561,7 +16578,7 @@
                         <a:buNone/>
                       </a:pPr>
                       <a:r>
-                        <a:rPr lang="en-US" sz="1200" b="1" dirty="0">
+                        <a:rPr lang="en-US" sz="1050" b="1" dirty="0">
                           <a:solidFill>
                             <a:srgbClr val="FFFFFF"/>
                           </a:solidFill>
@@ -16569,9 +16586,9 @@
                           <a:ea typeface="Calibri" pitchFamily="34" charset="-122"/>
                           <a:cs typeface="Calibri" pitchFamily="34" charset="-120"/>
                         </a:rPr>
-                        <a:t>Type</a:t>
+                        <a:t>Reported effects</a:t>
                       </a:r>
-                      <a:endParaRPr lang="en-US" sz="1200" dirty="0">
+                      <a:endParaRPr lang="en-US" sz="1050" dirty="0">
                         <a:latin typeface="Calibri" charset="0"/>
                         <a:ea typeface="Calibri" charset="0"/>
                         <a:cs typeface="Calibri" charset="0"/>
@@ -16629,7 +16646,7 @@
                         <a:buNone/>
                       </a:pPr>
                       <a:r>
-                        <a:rPr lang="en-US" sz="1200" b="1" dirty="0">
+                        <a:rPr lang="en-US" sz="1050" b="1" dirty="0">
                           <a:solidFill>
                             <a:srgbClr val="FFFFFF"/>
                           </a:solidFill>
@@ -16637,77 +16654,9 @@
                           <a:ea typeface="Calibri" pitchFamily="34" charset="-122"/>
                           <a:cs typeface="Calibri" pitchFamily="34" charset="-120"/>
                         </a:rPr>
-                        <a:t>Reported effects</a:t>
+                        <a:t>Record</a:t>
                       </a:r>
-                      <a:endParaRPr lang="en-US" sz="1200" dirty="0">
-                        <a:latin typeface="Calibri" charset="0"/>
-                        <a:ea typeface="Calibri" charset="0"/>
-                        <a:cs typeface="Calibri" charset="0"/>
-                      </a:endParaRPr>
-                    </a:p>
-                  </a:txBody>
-                  <a:tcPr anchor="ctr">
-                    <a:lnL w="6350" cap="flat" cmpd="sng" algn="ctr">
-                      <a:solidFill>
-                        <a:srgbClr val="E2E8EC"/>
-                      </a:solidFill>
-                      <a:prstDash val="solid"/>
-                      <a:round/>
-                      <a:headEnd type="none" w="med" len="med"/>
-                      <a:tailEnd type="none" w="med" len="med"/>
-                    </a:lnL>
-                    <a:lnR w="6350" cap="flat" cmpd="sng" algn="ctr">
-                      <a:solidFill>
-                        <a:srgbClr val="E2E8EC"/>
-                      </a:solidFill>
-                      <a:prstDash val="solid"/>
-                      <a:round/>
-                      <a:headEnd type="none" w="med" len="med"/>
-                      <a:tailEnd type="none" w="med" len="med"/>
-                    </a:lnR>
-                    <a:lnT w="6350" cap="flat" cmpd="sng" algn="ctr">
-                      <a:solidFill>
-                        <a:srgbClr val="E2E8EC"/>
-                      </a:solidFill>
-                      <a:prstDash val="solid"/>
-                      <a:round/>
-                      <a:headEnd type="none" w="med" len="med"/>
-                      <a:tailEnd type="none" w="med" len="med"/>
-                    </a:lnT>
-                    <a:lnB w="6350" cap="flat" cmpd="sng" algn="ctr">
-                      <a:solidFill>
-                        <a:srgbClr val="E2E8EC"/>
-                      </a:solidFill>
-                      <a:prstDash val="solid"/>
-                      <a:round/>
-                      <a:headEnd type="none" w="med" len="med"/>
-                      <a:tailEnd type="none" w="med" len="med"/>
-                    </a:lnB>
-                    <a:solidFill>
-                      <a:srgbClr val="065A82"/>
-                    </a:solidFill>
-                  </a:tcPr>
-                </a:tc>
-                <a:tc>
-                  <a:txBody>
-                    <a:bodyPr/>
-                    <a:lstStyle/>
-                    <a:p>
-                      <a:pPr marL="0" indent="0" algn="l">
-                        <a:buNone/>
-                      </a:pPr>
-                      <a:r>
-                        <a:rPr lang="en-US" sz="1200" b="1" dirty="0">
-                          <a:solidFill>
-                            <a:srgbClr val="FFFFFF"/>
-                          </a:solidFill>
-                          <a:latin typeface="Calibri" pitchFamily="34" charset="0"/>
-                          <a:ea typeface="Calibri" pitchFamily="34" charset="-122"/>
-                          <a:cs typeface="Calibri" pitchFamily="34" charset="-120"/>
-                        </a:rPr>
-                        <a:t>Senglea, public copy</a:t>
-                      </a:r>
-                      <a:endParaRPr lang="en-US" sz="1200" dirty="0">
+                      <a:endParaRPr lang="en-US" sz="1050" dirty="0">
                         <a:latin typeface="Calibri" charset="0"/>
                         <a:ea typeface="Calibri" charset="0"/>
                         <a:cs typeface="Calibri" charset="0"/>
@@ -16762,7 +16711,7 @@
                   </a:ext>
                 </a:extLst>
               </a:tr>
-              <a:tr h="347472">
+              <a:tr h="457200">
                 <a:tc>
                   <a:txBody>
                     <a:bodyPr/>
@@ -16772,7 +16721,7 @@
                         <a:buNone/>
                       </a:pPr>
                       <a:r>
-                        <a:rPr lang="en-US" sz="1200" b="1" dirty="0">
+                        <a:rPr lang="en-US" sz="1050" b="1" dirty="0">
                           <a:solidFill>
                             <a:srgbClr val="1A1A1A"/>
                           </a:solidFill>
@@ -16780,9 +16729,9 @@
                           <a:ea typeface="Calibri" pitchFamily="34" charset="-122"/>
                           <a:cs typeface="Calibri" pitchFamily="34" charset="-120"/>
                         </a:rPr>
-                        <a:t>25 Oct 2018</a:t>
+                        <a:t>30 Jun 2022</a:t>
                       </a:r>
-                      <a:endParaRPr lang="en-US" sz="1200" dirty="0">
+                      <a:endParaRPr lang="en-US" sz="1050" dirty="0">
                         <a:latin typeface="Calibri" charset="0"/>
                         <a:ea typeface="Calibri" charset="0"/>
                         <a:cs typeface="Calibri" charset="0"/>
@@ -16840,7 +16789,7 @@
                         <a:buNone/>
                       </a:pPr>
                       <a:r>
-                        <a:rPr lang="en-US" sz="1200" dirty="0">
+                        <a:rPr lang="en-US" sz="1050" dirty="0">
                           <a:solidFill>
                             <a:srgbClr val="1A1A1A"/>
                           </a:solidFill>
@@ -16848,9 +16797,9 @@
                           <a:ea typeface="Calibri" pitchFamily="34" charset="-122"/>
                           <a:cs typeface="Calibri" pitchFamily="34" charset="-120"/>
                         </a:rPr>
-                        <a:t>seismic tsunami</a:t>
+                        <a:t>flooding at Marsaskala, St Julian's and Qawra</a:t>
                       </a:r>
-                      <a:endParaRPr lang="en-US" sz="1200" dirty="0">
+                      <a:endParaRPr lang="en-US" sz="1050" dirty="0">
                         <a:latin typeface="Calibri" charset="0"/>
                         <a:ea typeface="Calibri" charset="0"/>
                         <a:cs typeface="Calibri" charset="0"/>
@@ -16908,7 +16857,7 @@
                         <a:buNone/>
                       </a:pPr>
                       <a:r>
-                        <a:rPr lang="en-US" sz="1200" dirty="0">
+                        <a:rPr lang="en-US" sz="1050" dirty="0">
                           <a:solidFill>
                             <a:srgbClr val="1A1A1A"/>
                           </a:solidFill>
@@ -16916,9 +16865,295 @@
                           <a:ea typeface="Calibri" pitchFamily="34" charset="-122"/>
                           <a:cs typeface="Calibri" pitchFamily="34" charset="-120"/>
                         </a:rPr>
-                        <a:t>excursions of some 25 cm at Portomaso</a:t>
+                        <a:t>no data</a:t>
                       </a:r>
-                      <a:endParaRPr lang="en-US" sz="1200" dirty="0">
+                      <a:endParaRPr lang="en-US" sz="1050" dirty="0">
+                        <a:latin typeface="Calibri" charset="0"/>
+                        <a:ea typeface="Calibri" charset="0"/>
+                        <a:cs typeface="Calibri" charset="0"/>
+                      </a:endParaRPr>
+                    </a:p>
+                  </a:txBody>
+                  <a:tcPr anchor="ctr">
+                    <a:lnL w="6350" cap="flat" cmpd="sng" algn="ctr">
+                      <a:solidFill>
+                        <a:srgbClr val="E2E8EC"/>
+                      </a:solidFill>
+                      <a:prstDash val="solid"/>
+                      <a:round/>
+                      <a:headEnd type="none" w="med" len="med"/>
+                      <a:tailEnd type="none" w="med" len="med"/>
+                    </a:lnL>
+                    <a:lnR w="6350" cap="flat" cmpd="sng" algn="ctr">
+                      <a:solidFill>
+                        <a:srgbClr val="E2E8EC"/>
+                      </a:solidFill>
+                      <a:prstDash val="solid"/>
+                      <a:round/>
+                      <a:headEnd type="none" w="med" len="med"/>
+                      <a:tailEnd type="none" w="med" len="med"/>
+                    </a:lnR>
+                    <a:lnT w="6350" cap="flat" cmpd="sng" algn="ctr">
+                      <a:solidFill>
+                        <a:srgbClr val="E2E8EC"/>
+                      </a:solidFill>
+                      <a:prstDash val="solid"/>
+                      <a:round/>
+                      <a:headEnd type="none" w="med" len="med"/>
+                      <a:tailEnd type="none" w="med" len="med"/>
+                    </a:lnT>
+                    <a:lnB w="6350" cap="flat" cmpd="sng" algn="ctr">
+                      <a:solidFill>
+                        <a:srgbClr val="E2E8EC"/>
+                      </a:solidFill>
+                      <a:prstDash val="solid"/>
+                      <a:round/>
+                      <a:headEnd type="none" w="med" len="med"/>
+                      <a:tailEnd type="none" w="med" len="med"/>
+                    </a:lnB>
+                    <a:solidFill>
+                      <a:srgbClr val="FFFFFF"/>
+                    </a:solidFill>
+                  </a:tcPr>
+                </a:tc>
+                <a:extLst>
+                  <a:ext uri="{0D108BD9-81ED-4DB2-BD59-A6C34878D82A}">
+                    <a16:rowId xmlns:a16="http://schemas.microsoft.com/office/drawing/2014/main" val="10001"/>
+                  </a:ext>
+                </a:extLst>
+              </a:tr>
+              <a:tr h="457200">
+                <a:tc>
+                  <a:txBody>
+                    <a:bodyPr/>
+                    <a:lstStyle/>
+                    <a:p>
+                      <a:pPr marL="0" indent="0" algn="l">
+                        <a:buNone/>
+                      </a:pPr>
+                      <a:r>
+                        <a:rPr lang="en-US" sz="1050" b="1" dirty="0">
+                          <a:solidFill>
+                            <a:srgbClr val="1A1A1A"/>
+                          </a:solidFill>
+                          <a:latin typeface="Calibri" pitchFamily="34" charset="0"/>
+                          <a:ea typeface="Calibri" pitchFamily="34" charset="-122"/>
+                          <a:cs typeface="Calibri" pitchFamily="34" charset="-120"/>
+                        </a:rPr>
+                        <a:t>1 Jul 2023</a:t>
+                      </a:r>
+                      <a:endParaRPr lang="en-US" sz="1050" dirty="0">
+                        <a:latin typeface="Calibri" charset="0"/>
+                        <a:ea typeface="Calibri" charset="0"/>
+                        <a:cs typeface="Calibri" charset="0"/>
+                      </a:endParaRPr>
+                    </a:p>
+                  </a:txBody>
+                  <a:tcPr anchor="ctr">
+                    <a:lnL w="6350" cap="flat" cmpd="sng" algn="ctr">
+                      <a:solidFill>
+                        <a:srgbClr val="E2E8EC"/>
+                      </a:solidFill>
+                      <a:prstDash val="solid"/>
+                      <a:round/>
+                      <a:headEnd type="none" w="med" len="med"/>
+                      <a:tailEnd type="none" w="med" len="med"/>
+                    </a:lnL>
+                    <a:lnR w="6350" cap="flat" cmpd="sng" algn="ctr">
+                      <a:solidFill>
+                        <a:srgbClr val="E2E8EC"/>
+                      </a:solidFill>
+                      <a:prstDash val="solid"/>
+                      <a:round/>
+                      <a:headEnd type="none" w="med" len="med"/>
+                      <a:tailEnd type="none" w="med" len="med"/>
+                    </a:lnR>
+                    <a:lnT w="6350" cap="flat" cmpd="sng" algn="ctr">
+                      <a:solidFill>
+                        <a:srgbClr val="E2E8EC"/>
+                      </a:solidFill>
+                      <a:prstDash val="solid"/>
+                      <a:round/>
+                      <a:headEnd type="none" w="med" len="med"/>
+                      <a:tailEnd type="none" w="med" len="med"/>
+                    </a:lnT>
+                    <a:lnB w="6350" cap="flat" cmpd="sng" algn="ctr">
+                      <a:solidFill>
+                        <a:srgbClr val="E2E8EC"/>
+                      </a:solidFill>
+                      <a:prstDash val="solid"/>
+                      <a:round/>
+                      <a:headEnd type="none" w="med" len="med"/>
+                      <a:tailEnd type="none" w="med" len="med"/>
+                    </a:lnB>
+                    <a:solidFill>
+                      <a:srgbClr val="EEF3F6"/>
+                    </a:solidFill>
+                  </a:tcPr>
+                </a:tc>
+                <a:tc>
+                  <a:txBody>
+                    <a:bodyPr/>
+                    <a:lstStyle/>
+                    <a:p>
+                      <a:pPr marL="0" indent="0" algn="l">
+                        <a:buNone/>
+                      </a:pPr>
+                      <a:r>
+                        <a:rPr lang="en-US" sz="1050" dirty="0">
+                          <a:solidFill>
+                            <a:srgbClr val="1A1A1A"/>
+                          </a:solidFill>
+                          <a:latin typeface="Calibri" pitchFamily="34" charset="0"/>
+                          <a:ea typeface="Calibri" pitchFamily="34" charset="-122"/>
+                          <a:cs typeface="Calibri" pitchFamily="34" charset="-120"/>
+                        </a:rPr>
+                        <a:t>flooding at Marsaskala and Xemxija</a:t>
+                      </a:r>
+                      <a:endParaRPr lang="en-US" sz="1050" dirty="0">
+                        <a:latin typeface="Calibri" charset="0"/>
+                        <a:ea typeface="Calibri" charset="0"/>
+                        <a:cs typeface="Calibri" charset="0"/>
+                      </a:endParaRPr>
+                    </a:p>
+                  </a:txBody>
+                  <a:tcPr anchor="ctr">
+                    <a:lnL w="6350" cap="flat" cmpd="sng" algn="ctr">
+                      <a:solidFill>
+                        <a:srgbClr val="E2E8EC"/>
+                      </a:solidFill>
+                      <a:prstDash val="solid"/>
+                      <a:round/>
+                      <a:headEnd type="none" w="med" len="med"/>
+                      <a:tailEnd type="none" w="med" len="med"/>
+                    </a:lnL>
+                    <a:lnR w="6350" cap="flat" cmpd="sng" algn="ctr">
+                      <a:solidFill>
+                        <a:srgbClr val="E2E8EC"/>
+                      </a:solidFill>
+                      <a:prstDash val="solid"/>
+                      <a:round/>
+                      <a:headEnd type="none" w="med" len="med"/>
+                      <a:tailEnd type="none" w="med" len="med"/>
+                    </a:lnR>
+                    <a:lnT w="6350" cap="flat" cmpd="sng" algn="ctr">
+                      <a:solidFill>
+                        <a:srgbClr val="E2E8EC"/>
+                      </a:solidFill>
+                      <a:prstDash val="solid"/>
+                      <a:round/>
+                      <a:headEnd type="none" w="med" len="med"/>
+                      <a:tailEnd type="none" w="med" len="med"/>
+                    </a:lnT>
+                    <a:lnB w="6350" cap="flat" cmpd="sng" algn="ctr">
+                      <a:solidFill>
+                        <a:srgbClr val="E2E8EC"/>
+                      </a:solidFill>
+                      <a:prstDash val="solid"/>
+                      <a:round/>
+                      <a:headEnd type="none" w="med" len="med"/>
+                      <a:tailEnd type="none" w="med" len="med"/>
+                    </a:lnB>
+                    <a:solidFill>
+                      <a:srgbClr val="EEF3F6"/>
+                    </a:solidFill>
+                  </a:tcPr>
+                </a:tc>
+                <a:tc>
+                  <a:txBody>
+                    <a:bodyPr/>
+                    <a:lstStyle/>
+                    <a:p>
+                      <a:pPr marL="0" indent="0" algn="l">
+                        <a:buNone/>
+                      </a:pPr>
+                      <a:r>
+                        <a:rPr lang="en-US" sz="1050" dirty="0">
+                          <a:solidFill>
+                            <a:srgbClr val="1A1A1A"/>
+                          </a:solidFill>
+                          <a:latin typeface="Calibri" pitchFamily="34" charset="0"/>
+                          <a:ea typeface="Calibri" pitchFamily="34" charset="-122"/>
+                          <a:cs typeface="Calibri" pitchFamily="34" charset="-120"/>
+                        </a:rPr>
+                        <a:t>displaced level, not usable</a:t>
+                      </a:r>
+                      <a:endParaRPr lang="en-US" sz="1050" dirty="0">
+                        <a:latin typeface="Calibri" charset="0"/>
+                        <a:ea typeface="Calibri" charset="0"/>
+                        <a:cs typeface="Calibri" charset="0"/>
+                      </a:endParaRPr>
+                    </a:p>
+                  </a:txBody>
+                  <a:tcPr anchor="ctr">
+                    <a:lnL w="6350" cap="flat" cmpd="sng" algn="ctr">
+                      <a:solidFill>
+                        <a:srgbClr val="E2E8EC"/>
+                      </a:solidFill>
+                      <a:prstDash val="solid"/>
+                      <a:round/>
+                      <a:headEnd type="none" w="med" len="med"/>
+                      <a:tailEnd type="none" w="med" len="med"/>
+                    </a:lnL>
+                    <a:lnR w="6350" cap="flat" cmpd="sng" algn="ctr">
+                      <a:solidFill>
+                        <a:srgbClr val="E2E8EC"/>
+                      </a:solidFill>
+                      <a:prstDash val="solid"/>
+                      <a:round/>
+                      <a:headEnd type="none" w="med" len="med"/>
+                      <a:tailEnd type="none" w="med" len="med"/>
+                    </a:lnR>
+                    <a:lnT w="6350" cap="flat" cmpd="sng" algn="ctr">
+                      <a:solidFill>
+                        <a:srgbClr val="E2E8EC"/>
+                      </a:solidFill>
+                      <a:prstDash val="solid"/>
+                      <a:round/>
+                      <a:headEnd type="none" w="med" len="med"/>
+                      <a:tailEnd type="none" w="med" len="med"/>
+                    </a:lnT>
+                    <a:lnB w="6350" cap="flat" cmpd="sng" algn="ctr">
+                      <a:solidFill>
+                        <a:srgbClr val="E2E8EC"/>
+                      </a:solidFill>
+                      <a:prstDash val="solid"/>
+                      <a:round/>
+                      <a:headEnd type="none" w="med" len="med"/>
+                      <a:tailEnd type="none" w="med" len="med"/>
+                    </a:lnB>
+                    <a:solidFill>
+                      <a:srgbClr val="EEF3F6"/>
+                    </a:solidFill>
+                  </a:tcPr>
+                </a:tc>
+                <a:extLst>
+                  <a:ext uri="{0D108BD9-81ED-4DB2-BD59-A6C34878D82A}">
+                    <a16:rowId xmlns:a16="http://schemas.microsoft.com/office/drawing/2014/main" val="10002"/>
+                  </a:ext>
+                </a:extLst>
+              </a:tr>
+              <a:tr h="457200">
+                <a:tc>
+                  <a:txBody>
+                    <a:bodyPr/>
+                    <a:lstStyle/>
+                    <a:p>
+                      <a:pPr marL="0" indent="0" algn="l">
+                        <a:buNone/>
+                      </a:pPr>
+                      <a:r>
+                        <a:rPr lang="en-US" sz="1050" b="1" dirty="0">
+                          <a:solidFill>
+                            <a:srgbClr val="1A1A1A"/>
+                          </a:solidFill>
+                          <a:latin typeface="Calibri" pitchFamily="34" charset="0"/>
+                          <a:ea typeface="Calibri" pitchFamily="34" charset="-122"/>
+                          <a:cs typeface="Calibri" pitchFamily="34" charset="-120"/>
+                        </a:rPr>
+                        <a:t>13 Jun 2024</a:t>
+                      </a:r>
+                      <a:endParaRPr lang="en-US" sz="1050" dirty="0">
                         <a:latin typeface="Calibri" charset="0"/>
                         <a:ea typeface="Calibri" charset="0"/>
                         <a:cs typeface="Calibri" charset="0"/>
@@ -16976,7 +17211,7 @@
                         <a:buNone/>
                       </a:pPr>
                       <a:r>
-                        <a:rPr lang="en-US" sz="1200" dirty="0">
+                        <a:rPr lang="en-US" sz="1050" dirty="0">
                           <a:solidFill>
                             <a:srgbClr val="1A1A1A"/>
                           </a:solidFill>
@@ -16984,363 +17219,9 @@
                           <a:ea typeface="Calibri" pitchFamily="34" charset="-122"/>
                           <a:cs typeface="Calibri" pitchFamily="34" charset="-120"/>
                         </a:rPr>
-                        <a:t>before installation</a:t>
+                        <a:t>flooding of the main square of Msida</a:t>
                       </a:r>
-                      <a:endParaRPr lang="en-US" sz="1200" dirty="0">
-                        <a:latin typeface="Calibri" charset="0"/>
-                        <a:ea typeface="Calibri" charset="0"/>
-                        <a:cs typeface="Calibri" charset="0"/>
-                      </a:endParaRPr>
-                    </a:p>
-                  </a:txBody>
-                  <a:tcPr anchor="ctr">
-                    <a:lnL w="6350" cap="flat" cmpd="sng" algn="ctr">
-                      <a:solidFill>
-                        <a:srgbClr val="E2E8EC"/>
-                      </a:solidFill>
-                      <a:prstDash val="solid"/>
-                      <a:round/>
-                      <a:headEnd type="none" w="med" len="med"/>
-                      <a:tailEnd type="none" w="med" len="med"/>
-                    </a:lnL>
-                    <a:lnR w="6350" cap="flat" cmpd="sng" algn="ctr">
-                      <a:solidFill>
-                        <a:srgbClr val="E2E8EC"/>
-                      </a:solidFill>
-                      <a:prstDash val="solid"/>
-                      <a:round/>
-                      <a:headEnd type="none" w="med" len="med"/>
-                      <a:tailEnd type="none" w="med" len="med"/>
-                    </a:lnR>
-                    <a:lnT w="6350" cap="flat" cmpd="sng" algn="ctr">
-                      <a:solidFill>
-                        <a:srgbClr val="E2E8EC"/>
-                      </a:solidFill>
-                      <a:prstDash val="solid"/>
-                      <a:round/>
-                      <a:headEnd type="none" w="med" len="med"/>
-                      <a:tailEnd type="none" w="med" len="med"/>
-                    </a:lnT>
-                    <a:lnB w="6350" cap="flat" cmpd="sng" algn="ctr">
-                      <a:solidFill>
-                        <a:srgbClr val="E2E8EC"/>
-                      </a:solidFill>
-                      <a:prstDash val="solid"/>
-                      <a:round/>
-                      <a:headEnd type="none" w="med" len="med"/>
-                      <a:tailEnd type="none" w="med" len="med"/>
-                    </a:lnB>
-                    <a:solidFill>
-                      <a:srgbClr val="FFFFFF"/>
-                    </a:solidFill>
-                  </a:tcPr>
-                </a:tc>
-                <a:extLst>
-                  <a:ext uri="{0D108BD9-81ED-4DB2-BD59-A6C34878D82A}">
-                    <a16:rowId xmlns:a16="http://schemas.microsoft.com/office/drawing/2014/main" val="10001"/>
-                  </a:ext>
-                </a:extLst>
-              </a:tr>
-              <a:tr h="347472">
-                <a:tc>
-                  <a:txBody>
-                    <a:bodyPr/>
-                    <a:lstStyle/>
-                    <a:p>
-                      <a:pPr marL="0" indent="0" algn="l">
-                        <a:buNone/>
-                      </a:pPr>
-                      <a:r>
-                        <a:rPr lang="en-US" sz="1200" b="1" dirty="0">
-                          <a:solidFill>
-                            <a:srgbClr val="1A1A1A"/>
-                          </a:solidFill>
-                          <a:latin typeface="Calibri" pitchFamily="34" charset="0"/>
-                          <a:ea typeface="Calibri" pitchFamily="34" charset="-122"/>
-                          <a:cs typeface="Calibri" pitchFamily="34" charset="-120"/>
-                        </a:rPr>
-                        <a:t>18 Jun 2019</a:t>
-                      </a:r>
-                      <a:endParaRPr lang="en-US" sz="1200" dirty="0">
-                        <a:latin typeface="Calibri" charset="0"/>
-                        <a:ea typeface="Calibri" charset="0"/>
-                        <a:cs typeface="Calibri" charset="0"/>
-                      </a:endParaRPr>
-                    </a:p>
-                  </a:txBody>
-                  <a:tcPr anchor="ctr">
-                    <a:lnL w="6350" cap="flat" cmpd="sng" algn="ctr">
-                      <a:solidFill>
-                        <a:srgbClr val="E2E8EC"/>
-                      </a:solidFill>
-                      <a:prstDash val="solid"/>
-                      <a:round/>
-                      <a:headEnd type="none" w="med" len="med"/>
-                      <a:tailEnd type="none" w="med" len="med"/>
-                    </a:lnL>
-                    <a:lnR w="6350" cap="flat" cmpd="sng" algn="ctr">
-                      <a:solidFill>
-                        <a:srgbClr val="E2E8EC"/>
-                      </a:solidFill>
-                      <a:prstDash val="solid"/>
-                      <a:round/>
-                      <a:headEnd type="none" w="med" len="med"/>
-                      <a:tailEnd type="none" w="med" len="med"/>
-                    </a:lnR>
-                    <a:lnT w="6350" cap="flat" cmpd="sng" algn="ctr">
-                      <a:solidFill>
-                        <a:srgbClr val="E2E8EC"/>
-                      </a:solidFill>
-                      <a:prstDash val="solid"/>
-                      <a:round/>
-                      <a:headEnd type="none" w="med" len="med"/>
-                      <a:tailEnd type="none" w="med" len="med"/>
-                    </a:lnT>
-                    <a:lnB w="6350" cap="flat" cmpd="sng" algn="ctr">
-                      <a:solidFill>
-                        <a:srgbClr val="E2E8EC"/>
-                      </a:solidFill>
-                      <a:prstDash val="solid"/>
-                      <a:round/>
-                      <a:headEnd type="none" w="med" len="med"/>
-                      <a:tailEnd type="none" w="med" len="med"/>
-                    </a:lnB>
-                    <a:solidFill>
-                      <a:srgbClr val="EEF3F6"/>
-                    </a:solidFill>
-                  </a:tcPr>
-                </a:tc>
-                <a:tc>
-                  <a:txBody>
-                    <a:bodyPr/>
-                    <a:lstStyle/>
-                    <a:p>
-                      <a:pPr marL="0" indent="0" algn="l">
-                        <a:buNone/>
-                      </a:pPr>
-                      <a:r>
-                        <a:rPr lang="en-US" sz="1200" dirty="0">
-                          <a:solidFill>
-                            <a:srgbClr val="1A1A1A"/>
-                          </a:solidFill>
-                          <a:latin typeface="Calibri" pitchFamily="34" charset="0"/>
-                          <a:ea typeface="Calibri" pitchFamily="34" charset="-122"/>
-                          <a:cs typeface="Calibri" pitchFamily="34" charset="-120"/>
-                        </a:rPr>
-                        <a:t>milgħuba</a:t>
-                      </a:r>
-                      <a:endParaRPr lang="en-US" sz="1200" dirty="0">
-                        <a:latin typeface="Calibri" charset="0"/>
-                        <a:ea typeface="Calibri" charset="0"/>
-                        <a:cs typeface="Calibri" charset="0"/>
-                      </a:endParaRPr>
-                    </a:p>
-                  </a:txBody>
-                  <a:tcPr anchor="ctr">
-                    <a:lnL w="6350" cap="flat" cmpd="sng" algn="ctr">
-                      <a:solidFill>
-                        <a:srgbClr val="E2E8EC"/>
-                      </a:solidFill>
-                      <a:prstDash val="solid"/>
-                      <a:round/>
-                      <a:headEnd type="none" w="med" len="med"/>
-                      <a:tailEnd type="none" w="med" len="med"/>
-                    </a:lnL>
-                    <a:lnR w="6350" cap="flat" cmpd="sng" algn="ctr">
-                      <a:solidFill>
-                        <a:srgbClr val="E2E8EC"/>
-                      </a:solidFill>
-                      <a:prstDash val="solid"/>
-                      <a:round/>
-                      <a:headEnd type="none" w="med" len="med"/>
-                      <a:tailEnd type="none" w="med" len="med"/>
-                    </a:lnR>
-                    <a:lnT w="6350" cap="flat" cmpd="sng" algn="ctr">
-                      <a:solidFill>
-                        <a:srgbClr val="E2E8EC"/>
-                      </a:solidFill>
-                      <a:prstDash val="solid"/>
-                      <a:round/>
-                      <a:headEnd type="none" w="med" len="med"/>
-                      <a:tailEnd type="none" w="med" len="med"/>
-                    </a:lnT>
-                    <a:lnB w="6350" cap="flat" cmpd="sng" algn="ctr">
-                      <a:solidFill>
-                        <a:srgbClr val="E2E8EC"/>
-                      </a:solidFill>
-                      <a:prstDash val="solid"/>
-                      <a:round/>
-                      <a:headEnd type="none" w="med" len="med"/>
-                      <a:tailEnd type="none" w="med" len="med"/>
-                    </a:lnB>
-                    <a:solidFill>
-                      <a:srgbClr val="EEF3F6"/>
-                    </a:solidFill>
-                  </a:tcPr>
-                </a:tc>
-                <a:tc>
-                  <a:txBody>
-                    <a:bodyPr/>
-                    <a:lstStyle/>
-                    <a:p>
-                      <a:pPr marL="0" indent="0" algn="l">
-                        <a:buNone/>
-                      </a:pPr>
-                      <a:r>
-                        <a:rPr lang="en-US" sz="1200" dirty="0">
-                          <a:solidFill>
-                            <a:srgbClr val="1A1A1A"/>
-                          </a:solidFill>
-                          <a:latin typeface="Calibri" pitchFamily="34" charset="0"/>
-                          <a:ea typeface="Calibri" pitchFamily="34" charset="-122"/>
-                          <a:cs typeface="Calibri" pitchFamily="34" charset="-120"/>
-                        </a:rPr>
-                        <a:t>sea bed exposed and quay overtopped in St Paul's Bay</a:t>
-                      </a:r>
-                      <a:endParaRPr lang="en-US" sz="1200" dirty="0">
-                        <a:latin typeface="Calibri" charset="0"/>
-                        <a:ea typeface="Calibri" charset="0"/>
-                        <a:cs typeface="Calibri" charset="0"/>
-                      </a:endParaRPr>
-                    </a:p>
-                  </a:txBody>
-                  <a:tcPr anchor="ctr">
-                    <a:lnL w="6350" cap="flat" cmpd="sng" algn="ctr">
-                      <a:solidFill>
-                        <a:srgbClr val="E2E8EC"/>
-                      </a:solidFill>
-                      <a:prstDash val="solid"/>
-                      <a:round/>
-                      <a:headEnd type="none" w="med" len="med"/>
-                      <a:tailEnd type="none" w="med" len="med"/>
-                    </a:lnL>
-                    <a:lnR w="6350" cap="flat" cmpd="sng" algn="ctr">
-                      <a:solidFill>
-                        <a:srgbClr val="E2E8EC"/>
-                      </a:solidFill>
-                      <a:prstDash val="solid"/>
-                      <a:round/>
-                      <a:headEnd type="none" w="med" len="med"/>
-                      <a:tailEnd type="none" w="med" len="med"/>
-                    </a:lnR>
-                    <a:lnT w="6350" cap="flat" cmpd="sng" algn="ctr">
-                      <a:solidFill>
-                        <a:srgbClr val="E2E8EC"/>
-                      </a:solidFill>
-                      <a:prstDash val="solid"/>
-                      <a:round/>
-                      <a:headEnd type="none" w="med" len="med"/>
-                      <a:tailEnd type="none" w="med" len="med"/>
-                    </a:lnT>
-                    <a:lnB w="6350" cap="flat" cmpd="sng" algn="ctr">
-                      <a:solidFill>
-                        <a:srgbClr val="E2E8EC"/>
-                      </a:solidFill>
-                      <a:prstDash val="solid"/>
-                      <a:round/>
-                      <a:headEnd type="none" w="med" len="med"/>
-                      <a:tailEnd type="none" w="med" len="med"/>
-                    </a:lnB>
-                    <a:solidFill>
-                      <a:srgbClr val="EEF3F6"/>
-                    </a:solidFill>
-                  </a:tcPr>
-                </a:tc>
-                <a:tc>
-                  <a:txBody>
-                    <a:bodyPr/>
-                    <a:lstStyle/>
-                    <a:p>
-                      <a:pPr marL="0" indent="0" algn="l">
-                        <a:buNone/>
-                      </a:pPr>
-                      <a:r>
-                        <a:rPr lang="en-US" sz="1200" dirty="0">
-                          <a:solidFill>
-                            <a:srgbClr val="1A1A1A"/>
-                          </a:solidFill>
-                          <a:latin typeface="Calibri" pitchFamily="34" charset="0"/>
-                          <a:ea typeface="Calibri" pitchFamily="34" charset="-122"/>
-                          <a:cs typeface="Calibri" pitchFamily="34" charset="-120"/>
-                        </a:rPr>
-                        <a:t>before installation</a:t>
-                      </a:r>
-                      <a:endParaRPr lang="en-US" sz="1200" dirty="0">
-                        <a:latin typeface="Calibri" charset="0"/>
-                        <a:ea typeface="Calibri" charset="0"/>
-                        <a:cs typeface="Calibri" charset="0"/>
-                      </a:endParaRPr>
-                    </a:p>
-                  </a:txBody>
-                  <a:tcPr anchor="ctr">
-                    <a:lnL w="6350" cap="flat" cmpd="sng" algn="ctr">
-                      <a:solidFill>
-                        <a:srgbClr val="E2E8EC"/>
-                      </a:solidFill>
-                      <a:prstDash val="solid"/>
-                      <a:round/>
-                      <a:headEnd type="none" w="med" len="med"/>
-                      <a:tailEnd type="none" w="med" len="med"/>
-                    </a:lnL>
-                    <a:lnR w="6350" cap="flat" cmpd="sng" algn="ctr">
-                      <a:solidFill>
-                        <a:srgbClr val="E2E8EC"/>
-                      </a:solidFill>
-                      <a:prstDash val="solid"/>
-                      <a:round/>
-                      <a:headEnd type="none" w="med" len="med"/>
-                      <a:tailEnd type="none" w="med" len="med"/>
-                    </a:lnR>
-                    <a:lnT w="6350" cap="flat" cmpd="sng" algn="ctr">
-                      <a:solidFill>
-                        <a:srgbClr val="E2E8EC"/>
-                      </a:solidFill>
-                      <a:prstDash val="solid"/>
-                      <a:round/>
-                      <a:headEnd type="none" w="med" len="med"/>
-                      <a:tailEnd type="none" w="med" len="med"/>
-                    </a:lnT>
-                    <a:lnB w="6350" cap="flat" cmpd="sng" algn="ctr">
-                      <a:solidFill>
-                        <a:srgbClr val="E2E8EC"/>
-                      </a:solidFill>
-                      <a:prstDash val="solid"/>
-                      <a:round/>
-                      <a:headEnd type="none" w="med" len="med"/>
-                      <a:tailEnd type="none" w="med" len="med"/>
-                    </a:lnB>
-                    <a:solidFill>
-                      <a:srgbClr val="EEF3F6"/>
-                    </a:solidFill>
-                  </a:tcPr>
-                </a:tc>
-                <a:extLst>
-                  <a:ext uri="{0D108BD9-81ED-4DB2-BD59-A6C34878D82A}">
-                    <a16:rowId xmlns:a16="http://schemas.microsoft.com/office/drawing/2014/main" val="10002"/>
-                  </a:ext>
-                </a:extLst>
-              </a:tr>
-              <a:tr h="347472">
-                <a:tc>
-                  <a:txBody>
-                    <a:bodyPr/>
-                    <a:lstStyle/>
-                    <a:p>
-                      <a:pPr marL="0" indent="0" algn="l">
-                        <a:buNone/>
-                      </a:pPr>
-                      <a:r>
-                        <a:rPr lang="en-US" sz="1200" b="1" dirty="0">
-                          <a:solidFill>
-                            <a:srgbClr val="1A1A1A"/>
-                          </a:solidFill>
-                          <a:latin typeface="Calibri" pitchFamily="34" charset="0"/>
-                          <a:ea typeface="Calibri" pitchFamily="34" charset="-122"/>
-                          <a:cs typeface="Calibri" pitchFamily="34" charset="-120"/>
-                        </a:rPr>
-                        <a:t>30 Jun 2022</a:t>
-                      </a:r>
-                      <a:endParaRPr lang="en-US" sz="1200" dirty="0">
+                      <a:endParaRPr lang="en-US" sz="1050" dirty="0">
                         <a:latin typeface="Calibri" charset="0"/>
                         <a:ea typeface="Calibri" charset="0"/>
                         <a:cs typeface="Calibri" charset="0"/>
@@ -17398,7 +17279,7 @@
                         <a:buNone/>
                       </a:pPr>
                       <a:r>
-                        <a:rPr lang="en-US" sz="1200" dirty="0">
+                        <a:rPr lang="en-US" sz="1050" dirty="0">
                           <a:solidFill>
                             <a:srgbClr val="1A1A1A"/>
                           </a:solidFill>
@@ -17406,145 +17287,9 @@
                           <a:ea typeface="Calibri" pitchFamily="34" charset="-122"/>
                           <a:cs typeface="Calibri" pitchFamily="34" charset="-120"/>
                         </a:rPr>
-                        <a:t>milgħuba</a:t>
+                        <a:t>displaced level, not usable</a:t>
                       </a:r>
-                      <a:endParaRPr lang="en-US" sz="1200" dirty="0">
-                        <a:latin typeface="Calibri" charset="0"/>
-                        <a:ea typeface="Calibri" charset="0"/>
-                        <a:cs typeface="Calibri" charset="0"/>
-                      </a:endParaRPr>
-                    </a:p>
-                  </a:txBody>
-                  <a:tcPr anchor="ctr">
-                    <a:lnL w="6350" cap="flat" cmpd="sng" algn="ctr">
-                      <a:solidFill>
-                        <a:srgbClr val="E2E8EC"/>
-                      </a:solidFill>
-                      <a:prstDash val="solid"/>
-                      <a:round/>
-                      <a:headEnd type="none" w="med" len="med"/>
-                      <a:tailEnd type="none" w="med" len="med"/>
-                    </a:lnL>
-                    <a:lnR w="6350" cap="flat" cmpd="sng" algn="ctr">
-                      <a:solidFill>
-                        <a:srgbClr val="E2E8EC"/>
-                      </a:solidFill>
-                      <a:prstDash val="solid"/>
-                      <a:round/>
-                      <a:headEnd type="none" w="med" len="med"/>
-                      <a:tailEnd type="none" w="med" len="med"/>
-                    </a:lnR>
-                    <a:lnT w="6350" cap="flat" cmpd="sng" algn="ctr">
-                      <a:solidFill>
-                        <a:srgbClr val="E2E8EC"/>
-                      </a:solidFill>
-                      <a:prstDash val="solid"/>
-                      <a:round/>
-                      <a:headEnd type="none" w="med" len="med"/>
-                      <a:tailEnd type="none" w="med" len="med"/>
-                    </a:lnT>
-                    <a:lnB w="6350" cap="flat" cmpd="sng" algn="ctr">
-                      <a:solidFill>
-                        <a:srgbClr val="E2E8EC"/>
-                      </a:solidFill>
-                      <a:prstDash val="solid"/>
-                      <a:round/>
-                      <a:headEnd type="none" w="med" len="med"/>
-                      <a:tailEnd type="none" w="med" len="med"/>
-                    </a:lnB>
-                    <a:solidFill>
-                      <a:srgbClr val="FFFFFF"/>
-                    </a:solidFill>
-                  </a:tcPr>
-                </a:tc>
-                <a:tc>
-                  <a:txBody>
-                    <a:bodyPr/>
-                    <a:lstStyle/>
-                    <a:p>
-                      <a:pPr marL="0" indent="0" algn="l">
-                        <a:buNone/>
-                      </a:pPr>
-                      <a:r>
-                        <a:rPr lang="en-US" sz="1200" dirty="0">
-                          <a:solidFill>
-                            <a:srgbClr val="1A1A1A"/>
-                          </a:solidFill>
-                          <a:latin typeface="Calibri" pitchFamily="34" charset="0"/>
-                          <a:ea typeface="Calibri" pitchFamily="34" charset="-122"/>
-                          <a:cs typeface="Calibri" pitchFamily="34" charset="-120"/>
-                        </a:rPr>
-                        <a:t>flooding at Marsaskala, St Julian's and Qawra</a:t>
-                      </a:r>
-                      <a:endParaRPr lang="en-US" sz="1200" dirty="0">
-                        <a:latin typeface="Calibri" charset="0"/>
-                        <a:ea typeface="Calibri" charset="0"/>
-                        <a:cs typeface="Calibri" charset="0"/>
-                      </a:endParaRPr>
-                    </a:p>
-                  </a:txBody>
-                  <a:tcPr anchor="ctr">
-                    <a:lnL w="6350" cap="flat" cmpd="sng" algn="ctr">
-                      <a:solidFill>
-                        <a:srgbClr val="E2E8EC"/>
-                      </a:solidFill>
-                      <a:prstDash val="solid"/>
-                      <a:round/>
-                      <a:headEnd type="none" w="med" len="med"/>
-                      <a:tailEnd type="none" w="med" len="med"/>
-                    </a:lnL>
-                    <a:lnR w="6350" cap="flat" cmpd="sng" algn="ctr">
-                      <a:solidFill>
-                        <a:srgbClr val="E2E8EC"/>
-                      </a:solidFill>
-                      <a:prstDash val="solid"/>
-                      <a:round/>
-                      <a:headEnd type="none" w="med" len="med"/>
-                      <a:tailEnd type="none" w="med" len="med"/>
-                    </a:lnR>
-                    <a:lnT w="6350" cap="flat" cmpd="sng" algn="ctr">
-                      <a:solidFill>
-                        <a:srgbClr val="E2E8EC"/>
-                      </a:solidFill>
-                      <a:prstDash val="solid"/>
-                      <a:round/>
-                      <a:headEnd type="none" w="med" len="med"/>
-                      <a:tailEnd type="none" w="med" len="med"/>
-                    </a:lnT>
-                    <a:lnB w="6350" cap="flat" cmpd="sng" algn="ctr">
-                      <a:solidFill>
-                        <a:srgbClr val="E2E8EC"/>
-                      </a:solidFill>
-                      <a:prstDash val="solid"/>
-                      <a:round/>
-                      <a:headEnd type="none" w="med" len="med"/>
-                      <a:tailEnd type="none" w="med" len="med"/>
-                    </a:lnB>
-                    <a:solidFill>
-                      <a:srgbClr val="FFFFFF"/>
-                    </a:solidFill>
-                  </a:tcPr>
-                </a:tc>
-                <a:tc>
-                  <a:txBody>
-                    <a:bodyPr/>
-                    <a:lstStyle/>
-                    <a:p>
-                      <a:pPr marL="0" indent="0" algn="l">
-                        <a:buNone/>
-                      </a:pPr>
-                      <a:r>
-                        <a:rPr lang="en-US" sz="1200" dirty="0">
-                          <a:solidFill>
-                            <a:srgbClr val="1A1A1A"/>
-                          </a:solidFill>
-                          <a:latin typeface="Calibri" pitchFamily="34" charset="0"/>
-                          <a:ea typeface="Calibri" pitchFamily="34" charset="-122"/>
-                          <a:cs typeface="Calibri" pitchFamily="34" charset="-120"/>
-                        </a:rPr>
-                        <a:t>no data, record resumes on 1 July</a:t>
-                      </a:r>
-                      <a:endParaRPr lang="en-US" sz="1200" dirty="0">
+                      <a:endParaRPr lang="en-US" sz="1050" dirty="0">
                         <a:latin typeface="Calibri" charset="0"/>
                         <a:ea typeface="Calibri" charset="0"/>
                         <a:cs typeface="Calibri" charset="0"/>
@@ -17599,582 +17344,66 @@
                   </a:ext>
                 </a:extLst>
               </a:tr>
-              <a:tr h="347472">
-                <a:tc>
-                  <a:txBody>
-                    <a:bodyPr/>
-                    <a:lstStyle/>
-                    <a:p>
-                      <a:pPr marL="0" indent="0" algn="l">
-                        <a:buNone/>
-                      </a:pPr>
-                      <a:r>
-                        <a:rPr lang="en-US" sz="1200" b="1" dirty="0">
-                          <a:solidFill>
-                            <a:srgbClr val="1A1A1A"/>
-                          </a:solidFill>
-                          <a:latin typeface="Calibri" pitchFamily="34" charset="0"/>
-                          <a:ea typeface="Calibri" pitchFamily="34" charset="-122"/>
-                          <a:cs typeface="Calibri" pitchFamily="34" charset="-120"/>
-                        </a:rPr>
-                        <a:t>1 Jul 2023</a:t>
-                      </a:r>
-                      <a:endParaRPr lang="en-US" sz="1200" dirty="0">
-                        <a:latin typeface="Calibri" charset="0"/>
-                        <a:ea typeface="Calibri" charset="0"/>
-                        <a:cs typeface="Calibri" charset="0"/>
-                      </a:endParaRPr>
-                    </a:p>
-                  </a:txBody>
-                  <a:tcPr anchor="ctr">
-                    <a:lnL w="6350" cap="flat" cmpd="sng" algn="ctr">
-                      <a:solidFill>
-                        <a:srgbClr val="E2E8EC"/>
-                      </a:solidFill>
-                      <a:prstDash val="solid"/>
-                      <a:round/>
-                      <a:headEnd type="none" w="med" len="med"/>
-                      <a:tailEnd type="none" w="med" len="med"/>
-                    </a:lnL>
-                    <a:lnR w="6350" cap="flat" cmpd="sng" algn="ctr">
-                      <a:solidFill>
-                        <a:srgbClr val="E2E8EC"/>
-                      </a:solidFill>
-                      <a:prstDash val="solid"/>
-                      <a:round/>
-                      <a:headEnd type="none" w="med" len="med"/>
-                      <a:tailEnd type="none" w="med" len="med"/>
-                    </a:lnR>
-                    <a:lnT w="6350" cap="flat" cmpd="sng" algn="ctr">
-                      <a:solidFill>
-                        <a:srgbClr val="E2E8EC"/>
-                      </a:solidFill>
-                      <a:prstDash val="solid"/>
-                      <a:round/>
-                      <a:headEnd type="none" w="med" len="med"/>
-                      <a:tailEnd type="none" w="med" len="med"/>
-                    </a:lnT>
-                    <a:lnB w="6350" cap="flat" cmpd="sng" algn="ctr">
-                      <a:solidFill>
-                        <a:srgbClr val="E2E8EC"/>
-                      </a:solidFill>
-                      <a:prstDash val="solid"/>
-                      <a:round/>
-                      <a:headEnd type="none" w="med" len="med"/>
-                      <a:tailEnd type="none" w="med" len="med"/>
-                    </a:lnB>
-                    <a:solidFill>
-                      <a:srgbClr val="EEF3F6"/>
-                    </a:solidFill>
-                  </a:tcPr>
-                </a:tc>
-                <a:tc>
-                  <a:txBody>
-                    <a:bodyPr/>
-                    <a:lstStyle/>
-                    <a:p>
-                      <a:pPr marL="0" indent="0" algn="l">
-                        <a:buNone/>
-                      </a:pPr>
-                      <a:r>
-                        <a:rPr lang="en-US" sz="1200" dirty="0">
-                          <a:solidFill>
-                            <a:srgbClr val="1A1A1A"/>
-                          </a:solidFill>
-                          <a:latin typeface="Calibri" pitchFamily="34" charset="0"/>
-                          <a:ea typeface="Calibri" pitchFamily="34" charset="-122"/>
-                          <a:cs typeface="Calibri" pitchFamily="34" charset="-120"/>
-                        </a:rPr>
-                        <a:t>milgħuba</a:t>
-                      </a:r>
-                      <a:endParaRPr lang="en-US" sz="1200" dirty="0">
-                        <a:latin typeface="Calibri" charset="0"/>
-                        <a:ea typeface="Calibri" charset="0"/>
-                        <a:cs typeface="Calibri" charset="0"/>
-                      </a:endParaRPr>
-                    </a:p>
-                  </a:txBody>
-                  <a:tcPr anchor="ctr">
-                    <a:lnL w="6350" cap="flat" cmpd="sng" algn="ctr">
-                      <a:solidFill>
-                        <a:srgbClr val="E2E8EC"/>
-                      </a:solidFill>
-                      <a:prstDash val="solid"/>
-                      <a:round/>
-                      <a:headEnd type="none" w="med" len="med"/>
-                      <a:tailEnd type="none" w="med" len="med"/>
-                    </a:lnL>
-                    <a:lnR w="6350" cap="flat" cmpd="sng" algn="ctr">
-                      <a:solidFill>
-                        <a:srgbClr val="E2E8EC"/>
-                      </a:solidFill>
-                      <a:prstDash val="solid"/>
-                      <a:round/>
-                      <a:headEnd type="none" w="med" len="med"/>
-                      <a:tailEnd type="none" w="med" len="med"/>
-                    </a:lnR>
-                    <a:lnT w="6350" cap="flat" cmpd="sng" algn="ctr">
-                      <a:solidFill>
-                        <a:srgbClr val="E2E8EC"/>
-                      </a:solidFill>
-                      <a:prstDash val="solid"/>
-                      <a:round/>
-                      <a:headEnd type="none" w="med" len="med"/>
-                      <a:tailEnd type="none" w="med" len="med"/>
-                    </a:lnT>
-                    <a:lnB w="6350" cap="flat" cmpd="sng" algn="ctr">
-                      <a:solidFill>
-                        <a:srgbClr val="E2E8EC"/>
-                      </a:solidFill>
-                      <a:prstDash val="solid"/>
-                      <a:round/>
-                      <a:headEnd type="none" w="med" len="med"/>
-                      <a:tailEnd type="none" w="med" len="med"/>
-                    </a:lnB>
-                    <a:solidFill>
-                      <a:srgbClr val="EEF3F6"/>
-                    </a:solidFill>
-                  </a:tcPr>
-                </a:tc>
-                <a:tc>
-                  <a:txBody>
-                    <a:bodyPr/>
-                    <a:lstStyle/>
-                    <a:p>
-                      <a:pPr marL="0" indent="0" algn="l">
-                        <a:buNone/>
-                      </a:pPr>
-                      <a:r>
-                        <a:rPr lang="en-US" sz="1200" dirty="0">
-                          <a:solidFill>
-                            <a:srgbClr val="1A1A1A"/>
-                          </a:solidFill>
-                          <a:latin typeface="Calibri" pitchFamily="34" charset="0"/>
-                          <a:ea typeface="Calibri" pitchFamily="34" charset="-122"/>
-                          <a:cs typeface="Calibri" pitchFamily="34" charset="-120"/>
-                        </a:rPr>
-                        <a:t>flooding at Marsaskala and Xemxija</a:t>
-                      </a:r>
-                      <a:endParaRPr lang="en-US" sz="1200" dirty="0">
-                        <a:latin typeface="Calibri" charset="0"/>
-                        <a:ea typeface="Calibri" charset="0"/>
-                        <a:cs typeface="Calibri" charset="0"/>
-                      </a:endParaRPr>
-                    </a:p>
-                  </a:txBody>
-                  <a:tcPr anchor="ctr">
-                    <a:lnL w="6350" cap="flat" cmpd="sng" algn="ctr">
-                      <a:solidFill>
-                        <a:srgbClr val="E2E8EC"/>
-                      </a:solidFill>
-                      <a:prstDash val="solid"/>
-                      <a:round/>
-                      <a:headEnd type="none" w="med" len="med"/>
-                      <a:tailEnd type="none" w="med" len="med"/>
-                    </a:lnL>
-                    <a:lnR w="6350" cap="flat" cmpd="sng" algn="ctr">
-                      <a:solidFill>
-                        <a:srgbClr val="E2E8EC"/>
-                      </a:solidFill>
-                      <a:prstDash val="solid"/>
-                      <a:round/>
-                      <a:headEnd type="none" w="med" len="med"/>
-                      <a:tailEnd type="none" w="med" len="med"/>
-                    </a:lnR>
-                    <a:lnT w="6350" cap="flat" cmpd="sng" algn="ctr">
-                      <a:solidFill>
-                        <a:srgbClr val="E2E8EC"/>
-                      </a:solidFill>
-                      <a:prstDash val="solid"/>
-                      <a:round/>
-                      <a:headEnd type="none" w="med" len="med"/>
-                      <a:tailEnd type="none" w="med" len="med"/>
-                    </a:lnT>
-                    <a:lnB w="6350" cap="flat" cmpd="sng" algn="ctr">
-                      <a:solidFill>
-                        <a:srgbClr val="E2E8EC"/>
-                      </a:solidFill>
-                      <a:prstDash val="solid"/>
-                      <a:round/>
-                      <a:headEnd type="none" w="med" len="med"/>
-                      <a:tailEnd type="none" w="med" len="med"/>
-                    </a:lnB>
-                    <a:solidFill>
-                      <a:srgbClr val="EEF3F6"/>
-                    </a:solidFill>
-                  </a:tcPr>
-                </a:tc>
-                <a:tc>
-                  <a:txBody>
-                    <a:bodyPr/>
-                    <a:lstStyle/>
-                    <a:p>
-                      <a:pPr marL="0" indent="0" algn="l">
-                        <a:buNone/>
-                      </a:pPr>
-                      <a:r>
-                        <a:rPr lang="en-US" sz="1200" dirty="0">
-                          <a:solidFill>
-                            <a:srgbClr val="1A1A1A"/>
-                          </a:solidFill>
-                          <a:latin typeface="Calibri" pitchFamily="34" charset="0"/>
-                          <a:ea typeface="Calibri" pitchFamily="34" charset="-122"/>
-                          <a:cs typeface="Calibri" pitchFamily="34" charset="-120"/>
-                        </a:rPr>
-                        <a:t>displaced level, not usable</a:t>
-                      </a:r>
-                      <a:endParaRPr lang="en-US" sz="1200" dirty="0">
-                        <a:latin typeface="Calibri" charset="0"/>
-                        <a:ea typeface="Calibri" charset="0"/>
-                        <a:cs typeface="Calibri" charset="0"/>
-                      </a:endParaRPr>
-                    </a:p>
-                  </a:txBody>
-                  <a:tcPr anchor="ctr">
-                    <a:lnL w="6350" cap="flat" cmpd="sng" algn="ctr">
-                      <a:solidFill>
-                        <a:srgbClr val="E2E8EC"/>
-                      </a:solidFill>
-                      <a:prstDash val="solid"/>
-                      <a:round/>
-                      <a:headEnd type="none" w="med" len="med"/>
-                      <a:tailEnd type="none" w="med" len="med"/>
-                    </a:lnL>
-                    <a:lnR w="6350" cap="flat" cmpd="sng" algn="ctr">
-                      <a:solidFill>
-                        <a:srgbClr val="E2E8EC"/>
-                      </a:solidFill>
-                      <a:prstDash val="solid"/>
-                      <a:round/>
-                      <a:headEnd type="none" w="med" len="med"/>
-                      <a:tailEnd type="none" w="med" len="med"/>
-                    </a:lnR>
-                    <a:lnT w="6350" cap="flat" cmpd="sng" algn="ctr">
-                      <a:solidFill>
-                        <a:srgbClr val="E2E8EC"/>
-                      </a:solidFill>
-                      <a:prstDash val="solid"/>
-                      <a:round/>
-                      <a:headEnd type="none" w="med" len="med"/>
-                      <a:tailEnd type="none" w="med" len="med"/>
-                    </a:lnT>
-                    <a:lnB w="6350" cap="flat" cmpd="sng" algn="ctr">
-                      <a:solidFill>
-                        <a:srgbClr val="E2E8EC"/>
-                      </a:solidFill>
-                      <a:prstDash val="solid"/>
-                      <a:round/>
-                      <a:headEnd type="none" w="med" len="med"/>
-                      <a:tailEnd type="none" w="med" len="med"/>
-                    </a:lnB>
-                    <a:solidFill>
-                      <a:srgbClr val="EEF3F6"/>
-                    </a:solidFill>
-                  </a:tcPr>
-                </a:tc>
-                <a:extLst>
-                  <a:ext uri="{0D108BD9-81ED-4DB2-BD59-A6C34878D82A}">
-                    <a16:rowId xmlns:a16="http://schemas.microsoft.com/office/drawing/2014/main" val="10004"/>
-                  </a:ext>
-                </a:extLst>
-              </a:tr>
-              <a:tr h="347472">
-                <a:tc>
-                  <a:txBody>
-                    <a:bodyPr/>
-                    <a:lstStyle/>
-                    <a:p>
-                      <a:pPr marL="0" indent="0" algn="l">
-                        <a:buNone/>
-                      </a:pPr>
-                      <a:r>
-                        <a:rPr lang="en-US" sz="1200" b="1" dirty="0">
-                          <a:solidFill>
-                            <a:srgbClr val="1A1A1A"/>
-                          </a:solidFill>
-                          <a:latin typeface="Calibri" pitchFamily="34" charset="0"/>
-                          <a:ea typeface="Calibri" pitchFamily="34" charset="-122"/>
-                          <a:cs typeface="Calibri" pitchFamily="34" charset="-120"/>
-                        </a:rPr>
-                        <a:t>13 Jun 2024</a:t>
-                      </a:r>
-                      <a:endParaRPr lang="en-US" sz="1200" dirty="0">
-                        <a:latin typeface="Calibri" charset="0"/>
-                        <a:ea typeface="Calibri" charset="0"/>
-                        <a:cs typeface="Calibri" charset="0"/>
-                      </a:endParaRPr>
-                    </a:p>
-                  </a:txBody>
-                  <a:tcPr anchor="ctr">
-                    <a:lnL w="6350" cap="flat" cmpd="sng" algn="ctr">
-                      <a:solidFill>
-                        <a:srgbClr val="E2E8EC"/>
-                      </a:solidFill>
-                      <a:prstDash val="solid"/>
-                      <a:round/>
-                      <a:headEnd type="none" w="med" len="med"/>
-                      <a:tailEnd type="none" w="med" len="med"/>
-                    </a:lnL>
-                    <a:lnR w="6350" cap="flat" cmpd="sng" algn="ctr">
-                      <a:solidFill>
-                        <a:srgbClr val="E2E8EC"/>
-                      </a:solidFill>
-                      <a:prstDash val="solid"/>
-                      <a:round/>
-                      <a:headEnd type="none" w="med" len="med"/>
-                      <a:tailEnd type="none" w="med" len="med"/>
-                    </a:lnR>
-                    <a:lnT w="6350" cap="flat" cmpd="sng" algn="ctr">
-                      <a:solidFill>
-                        <a:srgbClr val="E2E8EC"/>
-                      </a:solidFill>
-                      <a:prstDash val="solid"/>
-                      <a:round/>
-                      <a:headEnd type="none" w="med" len="med"/>
-                      <a:tailEnd type="none" w="med" len="med"/>
-                    </a:lnT>
-                    <a:lnB w="6350" cap="flat" cmpd="sng" algn="ctr">
-                      <a:solidFill>
-                        <a:srgbClr val="E2E8EC"/>
-                      </a:solidFill>
-                      <a:prstDash val="solid"/>
-                      <a:round/>
-                      <a:headEnd type="none" w="med" len="med"/>
-                      <a:tailEnd type="none" w="med" len="med"/>
-                    </a:lnB>
-                    <a:solidFill>
-                      <a:srgbClr val="FFFFFF"/>
-                    </a:solidFill>
-                  </a:tcPr>
-                </a:tc>
-                <a:tc>
-                  <a:txBody>
-                    <a:bodyPr/>
-                    <a:lstStyle/>
-                    <a:p>
-                      <a:pPr marL="0" indent="0" algn="l">
-                        <a:buNone/>
-                      </a:pPr>
-                      <a:r>
-                        <a:rPr lang="en-US" sz="1200" dirty="0">
-                          <a:solidFill>
-                            <a:srgbClr val="1A1A1A"/>
-                          </a:solidFill>
-                          <a:latin typeface="Calibri" pitchFamily="34" charset="0"/>
-                          <a:ea typeface="Calibri" pitchFamily="34" charset="-122"/>
-                          <a:cs typeface="Calibri" pitchFamily="34" charset="-120"/>
-                        </a:rPr>
-                        <a:t>meteotsunami</a:t>
-                      </a:r>
-                      <a:endParaRPr lang="en-US" sz="1200" dirty="0">
-                        <a:latin typeface="Calibri" charset="0"/>
-                        <a:ea typeface="Calibri" charset="0"/>
-                        <a:cs typeface="Calibri" charset="0"/>
-                      </a:endParaRPr>
-                    </a:p>
-                  </a:txBody>
-                  <a:tcPr anchor="ctr">
-                    <a:lnL w="6350" cap="flat" cmpd="sng" algn="ctr">
-                      <a:solidFill>
-                        <a:srgbClr val="E2E8EC"/>
-                      </a:solidFill>
-                      <a:prstDash val="solid"/>
-                      <a:round/>
-                      <a:headEnd type="none" w="med" len="med"/>
-                      <a:tailEnd type="none" w="med" len="med"/>
-                    </a:lnL>
-                    <a:lnR w="6350" cap="flat" cmpd="sng" algn="ctr">
-                      <a:solidFill>
-                        <a:srgbClr val="E2E8EC"/>
-                      </a:solidFill>
-                      <a:prstDash val="solid"/>
-                      <a:round/>
-                      <a:headEnd type="none" w="med" len="med"/>
-                      <a:tailEnd type="none" w="med" len="med"/>
-                    </a:lnR>
-                    <a:lnT w="6350" cap="flat" cmpd="sng" algn="ctr">
-                      <a:solidFill>
-                        <a:srgbClr val="E2E8EC"/>
-                      </a:solidFill>
-                      <a:prstDash val="solid"/>
-                      <a:round/>
-                      <a:headEnd type="none" w="med" len="med"/>
-                      <a:tailEnd type="none" w="med" len="med"/>
-                    </a:lnT>
-                    <a:lnB w="6350" cap="flat" cmpd="sng" algn="ctr">
-                      <a:solidFill>
-                        <a:srgbClr val="E2E8EC"/>
-                      </a:solidFill>
-                      <a:prstDash val="solid"/>
-                      <a:round/>
-                      <a:headEnd type="none" w="med" len="med"/>
-                      <a:tailEnd type="none" w="med" len="med"/>
-                    </a:lnB>
-                    <a:solidFill>
-                      <a:srgbClr val="FFFFFF"/>
-                    </a:solidFill>
-                  </a:tcPr>
-                </a:tc>
-                <a:tc>
-                  <a:txBody>
-                    <a:bodyPr/>
-                    <a:lstStyle/>
-                    <a:p>
-                      <a:pPr marL="0" indent="0" algn="l">
-                        <a:buNone/>
-                      </a:pPr>
-                      <a:r>
-                        <a:rPr lang="en-US" sz="1200" dirty="0">
-                          <a:solidFill>
-                            <a:srgbClr val="1A1A1A"/>
-                          </a:solidFill>
-                          <a:latin typeface="Calibri" pitchFamily="34" charset="0"/>
-                          <a:ea typeface="Calibri" pitchFamily="34" charset="-122"/>
-                          <a:cs typeface="Calibri" pitchFamily="34" charset="-120"/>
-                        </a:rPr>
-                        <a:t>flooding of the main square of Msida</a:t>
-                      </a:r>
-                      <a:endParaRPr lang="en-US" sz="1200" dirty="0">
-                        <a:latin typeface="Calibri" charset="0"/>
-                        <a:ea typeface="Calibri" charset="0"/>
-                        <a:cs typeface="Calibri" charset="0"/>
-                      </a:endParaRPr>
-                    </a:p>
-                  </a:txBody>
-                  <a:tcPr anchor="ctr">
-                    <a:lnL w="6350" cap="flat" cmpd="sng" algn="ctr">
-                      <a:solidFill>
-                        <a:srgbClr val="E2E8EC"/>
-                      </a:solidFill>
-                      <a:prstDash val="solid"/>
-                      <a:round/>
-                      <a:headEnd type="none" w="med" len="med"/>
-                      <a:tailEnd type="none" w="med" len="med"/>
-                    </a:lnL>
-                    <a:lnR w="6350" cap="flat" cmpd="sng" algn="ctr">
-                      <a:solidFill>
-                        <a:srgbClr val="E2E8EC"/>
-                      </a:solidFill>
-                      <a:prstDash val="solid"/>
-                      <a:round/>
-                      <a:headEnd type="none" w="med" len="med"/>
-                      <a:tailEnd type="none" w="med" len="med"/>
-                    </a:lnR>
-                    <a:lnT w="6350" cap="flat" cmpd="sng" algn="ctr">
-                      <a:solidFill>
-                        <a:srgbClr val="E2E8EC"/>
-                      </a:solidFill>
-                      <a:prstDash val="solid"/>
-                      <a:round/>
-                      <a:headEnd type="none" w="med" len="med"/>
-                      <a:tailEnd type="none" w="med" len="med"/>
-                    </a:lnT>
-                    <a:lnB w="6350" cap="flat" cmpd="sng" algn="ctr">
-                      <a:solidFill>
-                        <a:srgbClr val="E2E8EC"/>
-                      </a:solidFill>
-                      <a:prstDash val="solid"/>
-                      <a:round/>
-                      <a:headEnd type="none" w="med" len="med"/>
-                      <a:tailEnd type="none" w="med" len="med"/>
-                    </a:lnB>
-                    <a:solidFill>
-                      <a:srgbClr val="FFFFFF"/>
-                    </a:solidFill>
-                  </a:tcPr>
-                </a:tc>
-                <a:tc>
-                  <a:txBody>
-                    <a:bodyPr/>
-                    <a:lstStyle/>
-                    <a:p>
-                      <a:pPr marL="0" indent="0" algn="l">
-                        <a:buNone/>
-                      </a:pPr>
-                      <a:r>
-                        <a:rPr lang="en-US" sz="1200" dirty="0">
-                          <a:solidFill>
-                            <a:srgbClr val="1A1A1A"/>
-                          </a:solidFill>
-                          <a:latin typeface="Calibri" pitchFamily="34" charset="0"/>
-                          <a:ea typeface="Calibri" pitchFamily="34" charset="-122"/>
-                          <a:cs typeface="Calibri" pitchFamily="34" charset="-120"/>
-                        </a:rPr>
-                        <a:t>displaced level, not usable</a:t>
-                      </a:r>
-                      <a:endParaRPr lang="en-US" sz="1200" dirty="0">
-                        <a:latin typeface="Calibri" charset="0"/>
-                        <a:ea typeface="Calibri" charset="0"/>
-                        <a:cs typeface="Calibri" charset="0"/>
-                      </a:endParaRPr>
-                    </a:p>
-                  </a:txBody>
-                  <a:tcPr anchor="ctr">
-                    <a:lnL w="6350" cap="flat" cmpd="sng" algn="ctr">
-                      <a:solidFill>
-                        <a:srgbClr val="E2E8EC"/>
-                      </a:solidFill>
-                      <a:prstDash val="solid"/>
-                      <a:round/>
-                      <a:headEnd type="none" w="med" len="med"/>
-                      <a:tailEnd type="none" w="med" len="med"/>
-                    </a:lnL>
-                    <a:lnR w="6350" cap="flat" cmpd="sng" algn="ctr">
-                      <a:solidFill>
-                        <a:srgbClr val="E2E8EC"/>
-                      </a:solidFill>
-                      <a:prstDash val="solid"/>
-                      <a:round/>
-                      <a:headEnd type="none" w="med" len="med"/>
-                      <a:tailEnd type="none" w="med" len="med"/>
-                    </a:lnR>
-                    <a:lnT w="6350" cap="flat" cmpd="sng" algn="ctr">
-                      <a:solidFill>
-                        <a:srgbClr val="E2E8EC"/>
-                      </a:solidFill>
-                      <a:prstDash val="solid"/>
-                      <a:round/>
-                      <a:headEnd type="none" w="med" len="med"/>
-                      <a:tailEnd type="none" w="med" len="med"/>
-                    </a:lnT>
-                    <a:lnB w="6350" cap="flat" cmpd="sng" algn="ctr">
-                      <a:solidFill>
-                        <a:srgbClr val="E2E8EC"/>
-                      </a:solidFill>
-                      <a:prstDash val="solid"/>
-                      <a:round/>
-                      <a:headEnd type="none" w="med" len="med"/>
-                      <a:tailEnd type="none" w="med" len="med"/>
-                    </a:lnB>
-                    <a:solidFill>
-                      <a:srgbClr val="FFFFFF"/>
-                    </a:solidFill>
-                  </a:tcPr>
-                </a:tc>
-                <a:extLst>
-                  <a:ext uri="{0D108BD9-81ED-4DB2-BD59-A6C34878D82A}">
-                    <a16:rowId xmlns:a16="http://schemas.microsoft.com/office/drawing/2014/main" val="10005"/>
-                  </a:ext>
-                </a:extLst>
-              </a:tr>
             </a:tbl>
           </a:graphicData>
         </a:graphic>
       </p:graphicFrame>
       <p:sp>
         <p:nvSpPr>
-          <p:cNvPr id="6" name="Shape 3"/>
+          <p:cNvPr id="7" name="Text 3"/>
+          <p:cNvSpPr txBox="1"/>
+          <p:nvPr/>
+        </p:nvSpPr>
+        <p:spPr>
+          <a:xfrm>
+            <a:off x="7589520" y="4023360"/>
+            <a:ext cx="4032504" cy="640080"/>
+          </a:xfrm>
+          <a:prstGeom prst="rect">
+            <a:avLst/>
+          </a:prstGeom>
+          <a:noFill/>
+          <a:ln/>
+        </p:spPr>
+        <p:txBody>
+          <a:bodyPr wrap="square" lIns="0" tIns="0" rIns="0" bIns="0" rtlCol="0" anchor="t"/>
+          <a:lstStyle/>
+          <a:p>
+            <a:pPr marL="0" indent="0">
+              <a:lnSpc>
+                <a:spcPts val="1400"/>
+              </a:lnSpc>
+              <a:buNone/>
+            </a:pPr>
+            <a:r>
+              <a:rPr lang="en-US" sz="1050" dirty="0">
+                <a:solidFill>
+                  <a:srgbClr val="5F6368"/>
+                </a:solidFill>
+                <a:latin typeface="Calibri" pitchFamily="34" charset="0"/>
+                <a:ea typeface="Calibri" pitchFamily="34" charset="-122"/>
+                <a:cs typeface="Calibri" pitchFamily="34" charset="-120"/>
+              </a:rPr>
+              <a:t>Two earlier events, the seismic tsunami of 25 October 2018 and the milgħuba of 18 June 2019, precede the installation of the gauge in June 2021.</a:t>
+            </a:r>
+            <a:endParaRPr lang="en-US" sz="1050" dirty="0"/>
+          </a:p>
+        </p:txBody>
+      </p:sp>
+      <p:sp>
+        <p:nvSpPr>
+          <p:cNvPr id="6" name="Shape 4"/>
           <p:cNvSpPr/>
           <p:nvPr/>
         </p:nvSpPr>
         <p:spPr>
           <a:xfrm>
-            <a:off x="566928" y="4498848"/>
-            <a:ext cx="5440680" cy="1481328"/>
+            <a:off x="566928" y="4846320"/>
+            <a:ext cx="5440680" cy="1371600"/>
           </a:xfrm>
           <a:prstGeom prst="roundRect">
             <a:avLst>
-              <a:gd name="adj" fmla="val 3704"/>
+              <a:gd name="adj" fmla="val 4000"/>
             </a:avLst>
           </a:prstGeom>
           <a:solidFill>
@@ -18185,13 +17414,13 @@
       </p:sp>
       <p:sp>
         <p:nvSpPr>
-          <p:cNvPr id="7" name="Text 4"/>
+          <p:cNvPr id="9" name="Text 5"/>
           <p:cNvSpPr txBox="1"/>
           <p:nvPr/>
         </p:nvSpPr>
         <p:spPr>
           <a:xfrm>
-            <a:off x="841248" y="4663440"/>
+            <a:off x="841248" y="5010912"/>
             <a:ext cx="4892040" cy="274320"/>
           </a:xfrm>
           <a:prstGeom prst="rect">
@@ -18224,14 +17453,14 @@
       </p:sp>
       <p:sp>
         <p:nvSpPr>
-          <p:cNvPr id="5" name="Text 5"/>
+          <p:cNvPr id="10" name="Text 6"/>
           <p:cNvSpPr txBox="1"/>
           <p:nvPr/>
         </p:nvSpPr>
         <p:spPr>
           <a:xfrm>
-            <a:off x="841248" y="4992624"/>
-            <a:ext cx="4892040" cy="877824"/>
+            <a:off x="841248" y="5340096"/>
+            <a:ext cx="4892040" cy="768096"/>
           </a:xfrm>
           <a:prstGeom prst="rect">
             <a:avLst/>
@@ -18258,7 +17487,7 @@
                 <a:ea typeface="Calibri" pitchFamily="34" charset="-122"/>
                 <a:cs typeface="Calibri" pitchFamily="34" charset="-120"/>
               </a:rPr>
-              <a:t>Two windows are provisionally admitted to the analysis, 24 June to 31 December 2021 and 1 December 2022 to 31 March 2023, on monthly coverage and stability of the level. From April 2023 the level appears displaced by some 2 m and the gauge transmits by day only.</a:t>
+              <a:t>Two windows are provisionally admitted to the analysis, 24 June to 31 December 2021 and 1 December 2022 to 31 March 2023. From April 2023 the level appears displaced by some 2 m and the gauge transmits by day only.</a:t>
             </a:r>
             <a:endParaRPr lang="en-US" sz="1150" dirty="0"/>
           </a:p>
@@ -18266,18 +17495,18 @@
       </p:sp>
       <p:sp>
         <p:nvSpPr>
-          <p:cNvPr id="9" name="Shape 6"/>
+          <p:cNvPr id="11" name="Shape 7"/>
           <p:cNvSpPr/>
           <p:nvPr/>
         </p:nvSpPr>
         <p:spPr>
           <a:xfrm>
-            <a:off x="6181344" y="4498848"/>
-            <a:ext cx="5440680" cy="1481328"/>
+            <a:off x="6181344" y="4846320"/>
+            <a:ext cx="5440680" cy="1371600"/>
           </a:xfrm>
           <a:prstGeom prst="roundRect">
             <a:avLst>
-              <a:gd name="adj" fmla="val 3704"/>
+              <a:gd name="adj" fmla="val 4000"/>
             </a:avLst>
           </a:prstGeom>
           <a:solidFill>
@@ -18288,13 +17517,13 @@
       </p:sp>
       <p:sp>
         <p:nvSpPr>
-          <p:cNvPr id="10" name="Text 7"/>
+          <p:cNvPr id="12" name="Text 8"/>
           <p:cNvSpPr txBox="1"/>
           <p:nvPr/>
         </p:nvSpPr>
         <p:spPr>
           <a:xfrm>
-            <a:off x="6455664" y="4663440"/>
+            <a:off x="6455664" y="5010912"/>
             <a:ext cx="4892040" cy="274320"/>
           </a:xfrm>
           <a:prstGeom prst="rect">
@@ -18327,14 +17556,14 @@
       </p:sp>
       <p:sp>
         <p:nvSpPr>
-          <p:cNvPr id="11" name="Text 8"/>
+          <p:cNvPr id="13" name="Text 9"/>
           <p:cNvSpPr txBox="1"/>
           <p:nvPr/>
         </p:nvSpPr>
         <p:spPr>
           <a:xfrm>
-            <a:off x="6455664" y="4992624"/>
-            <a:ext cx="4892040" cy="877824"/>
+            <a:off x="6455664" y="5340096"/>
+            <a:ext cx="4892040" cy="768096"/>
           </a:xfrm>
           <a:prstGeom prst="rect">
             <a:avLst/>
@@ -18361,7 +17590,7 @@
                 <a:ea typeface="Calibri" pitchFamily="34" charset="-122"/>
                 <a:cs typeface="Calibri" pitchFamily="34" charset="-120"/>
               </a:rPr>
-              <a:t>None of the three events since installation is resolved in the public copy, and Portomaso returns no data from the IOC facility on those dates. The archive of the group, sea level and one-minute pressure, would therefore be the record against which the response surface is tested.</a:t>
+              <a:t>None of the three events since installation is resolved in the public copy. The archive of the group, sea level and one-minute pressure, would therefore be the record against which the response surface is tested.</a:t>
             </a:r>
             <a:endParaRPr lang="en-US" sz="1150" dirty="0"/>
           </a:p>

</xml_diff>

<commit_message>
docs(deck): condition the request for the archive on its availability
Edited in PowerPoint on the events slide of the full deck, and taken
into both generators and into the short deck.
</commit_message>
<xml_diff>
--- a/docs/valletta_model_concept_2026-10-08.pptx
+++ b/docs/valletta_model_concept_2026-10-08.pptx
@@ -2830,6 +2830,13 @@
           </a:solidFill>
           <a:ln/>
         </p:spPr>
+        <p:txBody>
+          <a:bodyPr/>
+          <a:lstStyle/>
+          <a:p>
+            <a:endParaRPr lang="it-IT"/>
+          </a:p>
+        </p:txBody>
       </p:sp>
       <p:sp>
         <p:nvSpPr>
@@ -3066,7 +3073,7 @@
         </p:nvGraphicFramePr>
         <p:xfrm>
           <a:off x="6446520" y="2103120"/>
-          <a:ext cx="5175504" cy="914400"/>
+          <a:ext cx="5175504" cy="1389888"/>
         </p:xfrm>
         <a:graphic>
           <a:graphicData uri="http://schemas.openxmlformats.org/drawingml/2006/table">
@@ -3964,6 +3971,13 @@
           </a:solidFill>
           <a:ln/>
         </p:spPr>
+        <p:txBody>
+          <a:bodyPr/>
+          <a:lstStyle/>
+          <a:p>
+            <a:endParaRPr lang="it-IT"/>
+          </a:p>
+        </p:txBody>
       </p:sp>
       <p:sp>
         <p:nvSpPr>
@@ -4067,6 +4081,13 @@
           </a:solidFill>
           <a:ln/>
         </p:spPr>
+        <p:txBody>
+          <a:bodyPr/>
+          <a:lstStyle/>
+          <a:p>
+            <a:endParaRPr lang="it-IT"/>
+          </a:p>
+        </p:txBody>
       </p:sp>
       <p:sp>
         <p:nvSpPr>
@@ -4436,6 +4457,13 @@
           </a:solidFill>
           <a:ln/>
         </p:spPr>
+        <p:txBody>
+          <a:bodyPr/>
+          <a:lstStyle/>
+          <a:p>
+            <a:endParaRPr lang="it-IT"/>
+          </a:p>
+        </p:txBody>
       </p:sp>
       <p:sp>
         <p:nvSpPr>
@@ -4612,6 +4640,13 @@
           </a:solidFill>
           <a:ln/>
         </p:spPr>
+        <p:txBody>
+          <a:bodyPr/>
+          <a:lstStyle/>
+          <a:p>
+            <a:endParaRPr lang="it-IT"/>
+          </a:p>
+        </p:txBody>
       </p:sp>
       <p:sp>
         <p:nvSpPr>
@@ -4818,6 +4853,13 @@
           </a:solidFill>
           <a:ln/>
         </p:spPr>
+        <p:txBody>
+          <a:bodyPr/>
+          <a:lstStyle/>
+          <a:p>
+            <a:endParaRPr lang="it-IT"/>
+          </a:p>
+        </p:txBody>
       </p:sp>
       <p:sp>
         <p:nvSpPr>
@@ -4921,6 +4963,13 @@
           </a:solidFill>
           <a:ln/>
         </p:spPr>
+        <p:txBody>
+          <a:bodyPr/>
+          <a:lstStyle/>
+          <a:p>
+            <a:endParaRPr lang="it-IT"/>
+          </a:p>
+        </p:txBody>
       </p:sp>
       <p:sp>
         <p:nvSpPr>
@@ -5066,6 +5115,13 @@
           </a:solidFill>
           <a:ln/>
         </p:spPr>
+        <p:txBody>
+          <a:bodyPr/>
+          <a:lstStyle/>
+          <a:p>
+            <a:endParaRPr lang="it-IT"/>
+          </a:p>
+        </p:txBody>
       </p:sp>
       <p:sp>
         <p:nvSpPr>
@@ -5211,6 +5267,13 @@
           </a:solidFill>
           <a:ln/>
         </p:spPr>
+        <p:txBody>
+          <a:bodyPr/>
+          <a:lstStyle/>
+          <a:p>
+            <a:endParaRPr lang="it-IT"/>
+          </a:p>
+        </p:txBody>
       </p:sp>
       <p:sp>
         <p:nvSpPr>
@@ -5532,7 +5595,7 @@
         </p:nvGraphicFramePr>
         <p:xfrm>
           <a:off x="566928" y="2194560"/>
-          <a:ext cx="5760720" cy="914400"/>
+          <a:ext cx="5760720" cy="3291840"/>
         </p:xfrm>
         <a:graphic>
           <a:graphicData uri="http://schemas.openxmlformats.org/drawingml/2006/table">
@@ -6855,6 +6918,13 @@
           </a:solidFill>
           <a:ln/>
         </p:spPr>
+        <p:txBody>
+          <a:bodyPr/>
+          <a:lstStyle/>
+          <a:p>
+            <a:endParaRPr lang="it-IT"/>
+          </a:p>
+        </p:txBody>
       </p:sp>
       <p:sp>
         <p:nvSpPr>
@@ -6958,6 +7028,13 @@
           </a:solidFill>
           <a:ln/>
         </p:spPr>
+        <p:txBody>
+          <a:bodyPr/>
+          <a:lstStyle/>
+          <a:p>
+            <a:endParaRPr lang="it-IT"/>
+          </a:p>
+        </p:txBody>
       </p:sp>
       <p:sp>
         <p:nvSpPr>
@@ -7201,6 +7278,13 @@
           </a:solidFill>
           <a:ln/>
         </p:spPr>
+        <p:txBody>
+          <a:bodyPr/>
+          <a:lstStyle/>
+          <a:p>
+            <a:endParaRPr lang="it-IT"/>
+          </a:p>
+        </p:txBody>
       </p:sp>
       <p:sp>
         <p:nvSpPr>
@@ -7344,6 +7428,13 @@
           </a:solidFill>
           <a:ln/>
         </p:spPr>
+        <p:txBody>
+          <a:bodyPr/>
+          <a:lstStyle/>
+          <a:p>
+            <a:endParaRPr lang="it-IT"/>
+          </a:p>
+        </p:txBody>
       </p:sp>
       <p:sp>
         <p:nvSpPr>
@@ -7487,6 +7578,13 @@
           </a:solidFill>
           <a:ln/>
         </p:spPr>
+        <p:txBody>
+          <a:bodyPr/>
+          <a:lstStyle/>
+          <a:p>
+            <a:endParaRPr lang="it-IT"/>
+          </a:p>
+        </p:txBody>
       </p:sp>
       <p:sp>
         <p:nvSpPr>
@@ -7630,6 +7728,13 @@
           </a:solidFill>
           <a:ln/>
         </p:spPr>
+        <p:txBody>
+          <a:bodyPr/>
+          <a:lstStyle/>
+          <a:p>
+            <a:endParaRPr lang="it-IT"/>
+          </a:p>
+        </p:txBody>
       </p:sp>
       <p:sp>
         <p:nvSpPr>
@@ -7773,6 +7878,13 @@
           </a:solidFill>
           <a:ln/>
         </p:spPr>
+        <p:txBody>
+          <a:bodyPr/>
+          <a:lstStyle/>
+          <a:p>
+            <a:endParaRPr lang="it-IT"/>
+          </a:p>
+        </p:txBody>
       </p:sp>
       <p:sp>
         <p:nvSpPr>
@@ -7916,6 +8028,13 @@
           </a:solidFill>
           <a:ln/>
         </p:spPr>
+        <p:txBody>
+          <a:bodyPr/>
+          <a:lstStyle/>
+          <a:p>
+            <a:endParaRPr lang="it-IT"/>
+          </a:p>
+        </p:txBody>
       </p:sp>
       <p:sp>
         <p:nvSpPr>
@@ -8140,6 +8259,13 @@
             <a:prstDash val="solid"/>
           </a:ln>
         </p:spPr>
+        <p:txBody>
+          <a:bodyPr/>
+          <a:lstStyle/>
+          <a:p>
+            <a:endParaRPr lang="it-IT"/>
+          </a:p>
+        </p:txBody>
       </p:sp>
       <p:sp>
         <p:nvSpPr>
@@ -8162,6 +8288,13 @@
           </a:solidFill>
           <a:ln/>
         </p:spPr>
+        <p:txBody>
+          <a:bodyPr/>
+          <a:lstStyle/>
+          <a:p>
+            <a:endParaRPr lang="it-IT"/>
+          </a:p>
+        </p:txBody>
       </p:sp>
       <p:sp>
         <p:nvSpPr>
@@ -8260,6 +8393,13 @@
           </a:solidFill>
           <a:ln/>
         </p:spPr>
+        <p:txBody>
+          <a:bodyPr/>
+          <a:lstStyle/>
+          <a:p>
+            <a:endParaRPr lang="it-IT"/>
+          </a:p>
+        </p:txBody>
       </p:sp>
       <p:sp>
         <p:nvSpPr>
@@ -8361,6 +8501,13 @@
           </a:solidFill>
           <a:ln/>
         </p:spPr>
+        <p:txBody>
+          <a:bodyPr/>
+          <a:lstStyle/>
+          <a:p>
+            <a:endParaRPr lang="it-IT"/>
+          </a:p>
+        </p:txBody>
       </p:sp>
       <p:sp>
         <p:nvSpPr>
@@ -8462,6 +8609,13 @@
           </a:solidFill>
           <a:ln/>
         </p:spPr>
+        <p:txBody>
+          <a:bodyPr/>
+          <a:lstStyle/>
+          <a:p>
+            <a:endParaRPr lang="it-IT"/>
+          </a:p>
+        </p:txBody>
       </p:sp>
       <p:sp>
         <p:nvSpPr>
@@ -8563,6 +8717,13 @@
           </a:solidFill>
           <a:ln/>
         </p:spPr>
+        <p:txBody>
+          <a:bodyPr/>
+          <a:lstStyle/>
+          <a:p>
+            <a:endParaRPr lang="it-IT"/>
+          </a:p>
+        </p:txBody>
       </p:sp>
       <p:sp>
         <p:nvSpPr>
@@ -8664,6 +8825,13 @@
           </a:solidFill>
           <a:ln/>
         </p:spPr>
+        <p:txBody>
+          <a:bodyPr/>
+          <a:lstStyle/>
+          <a:p>
+            <a:endParaRPr lang="it-IT"/>
+          </a:p>
+        </p:txBody>
       </p:sp>
       <p:sp>
         <p:nvSpPr>
@@ -8769,6 +8937,13 @@
           </a:solidFill>
           <a:ln/>
         </p:spPr>
+        <p:txBody>
+          <a:bodyPr/>
+          <a:lstStyle/>
+          <a:p>
+            <a:endParaRPr lang="it-IT"/>
+          </a:p>
+        </p:txBody>
       </p:sp>
       <p:sp>
         <p:nvSpPr>
@@ -11055,6 +11230,13 @@
           </a:solidFill>
           <a:ln/>
         </p:spPr>
+        <p:txBody>
+          <a:bodyPr/>
+          <a:lstStyle/>
+          <a:p>
+            <a:endParaRPr lang="it-IT"/>
+          </a:p>
+        </p:txBody>
       </p:sp>
       <p:sp>
         <p:nvSpPr>
@@ -11075,6 +11257,13 @@
           </a:solidFill>
           <a:ln/>
         </p:spPr>
+        <p:txBody>
+          <a:bodyPr/>
+          <a:lstStyle/>
+          <a:p>
+            <a:endParaRPr lang="it-IT"/>
+          </a:p>
+        </p:txBody>
       </p:sp>
       <p:sp>
         <p:nvSpPr>
@@ -11259,6 +11448,13 @@
           </a:solidFill>
           <a:ln/>
         </p:spPr>
+        <p:txBody>
+          <a:bodyPr/>
+          <a:lstStyle/>
+          <a:p>
+            <a:endParaRPr lang="it-IT"/>
+          </a:p>
+        </p:txBody>
       </p:sp>
       <p:sp>
         <p:nvSpPr>
@@ -11279,6 +11475,13 @@
           </a:solidFill>
           <a:ln/>
         </p:spPr>
+        <p:txBody>
+          <a:bodyPr/>
+          <a:lstStyle/>
+          <a:p>
+            <a:endParaRPr lang="it-IT"/>
+          </a:p>
+        </p:txBody>
       </p:sp>
       <p:sp>
         <p:nvSpPr>
@@ -11463,6 +11666,13 @@
           </a:solidFill>
           <a:ln/>
         </p:spPr>
+        <p:txBody>
+          <a:bodyPr/>
+          <a:lstStyle/>
+          <a:p>
+            <a:endParaRPr lang="it-IT"/>
+          </a:p>
+        </p:txBody>
       </p:sp>
       <p:sp>
         <p:nvSpPr>
@@ -11483,6 +11693,13 @@
           </a:solidFill>
           <a:ln/>
         </p:spPr>
+        <p:txBody>
+          <a:bodyPr/>
+          <a:lstStyle/>
+          <a:p>
+            <a:endParaRPr lang="it-IT"/>
+          </a:p>
+        </p:txBody>
       </p:sp>
       <p:sp>
         <p:nvSpPr>
@@ -11843,7 +12060,7 @@
         </p:nvGraphicFramePr>
         <p:xfrm>
           <a:off x="566928" y="2286000"/>
-          <a:ext cx="7772400" cy="914400"/>
+          <a:ext cx="7772400" cy="2400300"/>
         </p:xfrm>
         <a:graphic>
           <a:graphicData uri="http://schemas.openxmlformats.org/drawingml/2006/table">
@@ -14329,6 +14546,13 @@
           </a:solidFill>
           <a:ln/>
         </p:spPr>
+        <p:txBody>
+          <a:bodyPr/>
+          <a:lstStyle/>
+          <a:p>
+            <a:endParaRPr lang="it-IT"/>
+          </a:p>
+        </p:txBody>
       </p:sp>
       <p:sp>
         <p:nvSpPr>
@@ -14674,7 +14898,7 @@
         </p:nvGraphicFramePr>
         <p:xfrm>
           <a:off x="6583680" y="2103120"/>
-          <a:ext cx="5038344" cy="914400"/>
+          <a:ext cx="5038344" cy="1670304"/>
         </p:xfrm>
         <a:graphic>
           <a:graphicData uri="http://schemas.openxmlformats.org/drawingml/2006/table">
@@ -16119,6 +16343,13 @@
           </a:solidFill>
           <a:ln/>
         </p:spPr>
+        <p:txBody>
+          <a:bodyPr/>
+          <a:lstStyle/>
+          <a:p>
+            <a:endParaRPr lang="it-IT"/>
+          </a:p>
+        </p:txBody>
       </p:sp>
       <p:sp>
         <p:nvSpPr>
@@ -16471,7 +16702,7 @@
         </p:nvGraphicFramePr>
         <p:xfrm>
           <a:off x="7589520" y="2057400"/>
-          <a:ext cx="4032504" cy="914400"/>
+          <a:ext cx="4032504" cy="1828800"/>
         </p:xfrm>
         <a:graphic>
           <a:graphicData uri="http://schemas.openxmlformats.org/drawingml/2006/table">
@@ -17411,6 +17642,13 @@
           </a:solidFill>
           <a:ln/>
         </p:spPr>
+        <p:txBody>
+          <a:bodyPr/>
+          <a:lstStyle/>
+          <a:p>
+            <a:endParaRPr lang="it-IT"/>
+          </a:p>
+        </p:txBody>
       </p:sp>
       <p:sp>
         <p:nvSpPr>
@@ -17514,6 +17752,13 @@
           </a:solidFill>
           <a:ln/>
         </p:spPr>
+        <p:txBody>
+          <a:bodyPr/>
+          <a:lstStyle/>
+          <a:p>
+            <a:endParaRPr lang="it-IT"/>
+          </a:p>
+        </p:txBody>
       </p:sp>
       <p:sp>
         <p:nvSpPr>
@@ -17590,7 +17835,7 @@
                 <a:ea typeface="Calibri" pitchFamily="34" charset="-122"/>
                 <a:cs typeface="Calibri" pitchFamily="34" charset="-120"/>
               </a:rPr>
-              <a:t>None of the three events since installation is resolved in the public copy. The archive of the group, sea level and one-minute pressure, would therefore be the record against which the response surface is tested.</a:t>
+              <a:t>None of the three events since installation is resolved in the public copy. If available an archive of the group, with sea level and one-minute pressure, would therefore be the record against which the response surface is tested.</a:t>
             </a:r>
             <a:endParaRPr lang="en-US" sz="1150" dirty="0"/>
           </a:p>
@@ -17985,7 +18230,7 @@
         </p:nvGraphicFramePr>
         <p:xfrm>
           <a:off x="566928" y="3566160"/>
-          <a:ext cx="4937760" cy="914400"/>
+          <a:ext cx="4937760" cy="2057400"/>
         </p:xfrm>
         <a:graphic>
           <a:graphicData uri="http://schemas.openxmlformats.org/drawingml/2006/table">
@@ -18890,6 +19135,13 @@
           </a:solidFill>
           <a:ln/>
         </p:spPr>
+        <p:txBody>
+          <a:bodyPr/>
+          <a:lstStyle/>
+          <a:p>
+            <a:endParaRPr lang="it-IT"/>
+          </a:p>
+        </p:txBody>
       </p:sp>
       <p:sp>
         <p:nvSpPr>
@@ -18993,6 +19245,13 @@
           </a:solidFill>
           <a:ln/>
         </p:spPr>
+        <p:txBody>
+          <a:bodyPr/>
+          <a:lstStyle/>
+          <a:p>
+            <a:endParaRPr lang="it-IT"/>
+          </a:p>
+        </p:txBody>
       </p:sp>
       <p:sp>
         <p:nvSpPr>

</xml_diff>